<commit_message>
reformats data structure slides
</commit_message>
<xml_diff>
--- a/Python/Lesson 07 - Data Structures/Data Structures Basics.pptx
+++ b/Python/Lesson 07 - Data Structures/Data Structures Basics.pptx
@@ -223,7 +223,7 @@
           <a:p>
             <a:fld id="{941F8BC1-DC94-491B-AA44-0232F744EE98}" type="datetimeFigureOut">
               <a:rPr lang="en-US" smtClean="0"/>
-              <a:t>6/24/2026</a:t>
+              <a:t>7/22/2026</a:t>
             </a:fld>
             <a:endParaRPr lang="en-US"/>
           </a:p>
@@ -1132,7 +1132,7 @@
           <a:p>
             <a:fld id="{7A3E0868-4E26-4CDC-8A56-D70E2D8B12FE}" type="datetime3">
               <a:rPr lang="en-US" smtClean="0"/>
-              <a:t>24 June 2026</a:t>
+              <a:t>22 July 2026</a:t>
             </a:fld>
             <a:endParaRPr lang="en-US"/>
           </a:p>
@@ -3693,7 +3693,7 @@
           <a:p>
             <a:fld id="{A7B8021B-6105-4216-96FC-94348F216D0E}" type="datetime3">
               <a:rPr lang="en-US" smtClean="0"/>
-              <a:t>24 June 2026</a:t>
+              <a:t>22 July 2026</a:t>
             </a:fld>
             <a:endParaRPr lang="en-US"/>
           </a:p>
@@ -5390,7 +5390,7 @@
           <a:p>
             <a:fld id="{5D27CFAB-73E6-44A8-B862-B3306344E3F2}" type="datetime3">
               <a:rPr lang="en-US" smtClean="0"/>
-              <a:t>24 June 2026</a:t>
+              <a:t>22 July 2026</a:t>
             </a:fld>
             <a:endParaRPr lang="en-US"/>
           </a:p>
@@ -7180,7 +7180,7 @@
           <a:p>
             <a:fld id="{A9B2E784-A5F5-4301-881B-94AC8DBF9DED}" type="datetime3">
               <a:rPr lang="en-US" smtClean="0"/>
-              <a:t>24 June 2026</a:t>
+              <a:t>22 July 2026</a:t>
             </a:fld>
             <a:endParaRPr lang="en-US"/>
           </a:p>
@@ -7359,7 +7359,7 @@
           <a:p>
             <a:fld id="{18EAB3A5-9E92-4BB9-8F22-9632B4FBEDBA}" type="datetime3">
               <a:rPr lang="en-US" smtClean="0"/>
-              <a:t>24 June 2026</a:t>
+              <a:t>22 July 2026</a:t>
             </a:fld>
             <a:endParaRPr lang="en-US"/>
           </a:p>
@@ -7586,7 +7586,7 @@
           <a:p>
             <a:fld id="{40923810-5FB2-48C9-96CA-1DE2C4773142}" type="datetime3">
               <a:rPr lang="en-US" smtClean="0"/>
-              <a:t>24 June 2026</a:t>
+              <a:t>22 July 2026</a:t>
             </a:fld>
             <a:endParaRPr lang="en-US"/>
           </a:p>
@@ -7876,7 +7876,7 @@
           <a:p>
             <a:fld id="{E50EFF4B-86EB-42FB-93EA-7D8F9CB2466F}" type="datetime3">
               <a:rPr lang="en-US" smtClean="0"/>
-              <a:t>24 June 2026</a:t>
+              <a:t>22 July 2026</a:t>
             </a:fld>
             <a:endParaRPr lang="en-US"/>
           </a:p>
@@ -8488,7 +8488,7 @@
           <a:p>
             <a:fld id="{FB14FC24-E041-45E9-9A72-E5755A86890F}" type="datetime3">
               <a:rPr lang="en-US" smtClean="0"/>
-              <a:t>24 June 2026</a:t>
+              <a:t>22 July 2026</a:t>
             </a:fld>
             <a:endParaRPr lang="en-US"/>
           </a:p>
@@ -9348,7 +9348,7 @@
           <a:p>
             <a:fld id="{98A19125-94A7-4474-858C-FD9C4ABE9DDA}" type="datetime3">
               <a:rPr lang="en-US" smtClean="0"/>
-              <a:t>24 June 2026</a:t>
+              <a:t>22 July 2026</a:t>
             </a:fld>
             <a:endParaRPr lang="en-US"/>
           </a:p>
@@ -10451,7 +10451,7 @@
           <a:p>
             <a:fld id="{3BA0343D-C8D8-43CE-BB79-50DEA219DB07}" type="datetime3">
               <a:rPr lang="en-US" smtClean="0"/>
-              <a:t>24 June 2026</a:t>
+              <a:t>22 July 2026</a:t>
             </a:fld>
             <a:endParaRPr lang="en-US"/>
           </a:p>
@@ -10740,7 +10740,7 @@
           <a:p>
             <a:fld id="{453BD212-0B9F-4987-965F-AC83B2FC354F}" type="datetime3">
               <a:rPr lang="en-US" smtClean="0"/>
-              <a:t>24 June 2026</a:t>
+              <a:t>22 July 2026</a:t>
             </a:fld>
             <a:endParaRPr lang="en-US"/>
           </a:p>
@@ -10983,7 +10983,7 @@
           <a:p>
             <a:fld id="{6DDC931E-8CBE-4A3F-A034-9B6122C6DCDB}" type="datetime3">
               <a:rPr lang="en-US" smtClean="0"/>
-              <a:t>24 June 2026</a:t>
+              <a:t>22 July 2026</a:t>
             </a:fld>
             <a:endParaRPr lang="en-US"/>
           </a:p>
@@ -12749,7 +12749,7 @@
           <a:p>
             <a:fld id="{220AF9C2-5E8A-4308-AE6B-CA9B65007D0E}" type="datetime3">
               <a:rPr lang="en-US" smtClean="0"/>
-              <a:t>24 June 2026</a:t>
+              <a:t>22 July 2026</a:t>
             </a:fld>
             <a:endParaRPr lang="en-US"/>
           </a:p>
@@ -13062,7 +13062,7 @@
           <a:p>
             <a:fld id="{FF31E861-D2AF-431D-860B-DCF67C218052}" type="datetime3">
               <a:rPr lang="en-US" smtClean="0"/>
-              <a:t>24 June 2026</a:t>
+              <a:t>22 July 2026</a:t>
             </a:fld>
             <a:endParaRPr lang="en-US"/>
           </a:p>
@@ -13341,7 +13341,7 @@
           <a:p>
             <a:fld id="{D1DA25B2-AAF1-4C1F-AA38-12D5BFA7D4C8}" type="datetime3">
               <a:rPr lang="en-US" smtClean="0"/>
-              <a:t>24 June 2026</a:t>
+              <a:t>22 July 2026</a:t>
             </a:fld>
             <a:endParaRPr lang="en-US"/>
           </a:p>
@@ -13620,7 +13620,7 @@
           <a:p>
             <a:fld id="{A25C0F39-45D0-48E9-90B3-7FE8FCE561C8}" type="datetime3">
               <a:rPr lang="en-US" smtClean="0"/>
-              <a:t>24 June 2026</a:t>
+              <a:t>22 July 2026</a:t>
             </a:fld>
             <a:endParaRPr lang="en-US"/>
           </a:p>
@@ -14121,7 +14121,7 @@
           <a:p>
             <a:fld id="{9BAF1A3D-92FA-4F24-9781-74AFA516A230}" type="datetime3">
               <a:rPr lang="en-US" smtClean="0"/>
-              <a:t>24 June 2026</a:t>
+              <a:t>22 July 2026</a:t>
             </a:fld>
             <a:endParaRPr lang="en-US"/>
           </a:p>
@@ -14248,7 +14248,7 @@
           <a:p>
             <a:fld id="{5719C672-856D-4617-A693-8FE15749A9B7}" type="datetime3">
               <a:rPr lang="en-US" smtClean="0"/>
-              <a:t>24 June 2026</a:t>
+              <a:t>22 July 2026</a:t>
             </a:fld>
             <a:endParaRPr lang="en-US"/>
           </a:p>
@@ -14383,7 +14383,7 @@
           <a:p>
             <a:fld id="{5F6C764D-A39E-4C03-B161-E0BC66E8883B}" type="datetime3">
               <a:rPr lang="en-US" smtClean="0"/>
-              <a:t>24 June 2026</a:t>
+              <a:t>22 July 2026</a:t>
             </a:fld>
             <a:endParaRPr lang="en-US"/>
           </a:p>
@@ -14621,7 +14621,7 @@
           <a:p>
             <a:fld id="{6E3E33F9-20B7-4995-BE7D-165DBB597850}" type="datetime3">
               <a:rPr lang="en-US" smtClean="0"/>
-              <a:t>24 June 2026</a:t>
+              <a:t>22 July 2026</a:t>
             </a:fld>
             <a:endParaRPr lang="en-US"/>
           </a:p>
@@ -14734,7 +14734,7 @@
           <a:p>
             <a:fld id="{CD41C263-3501-4369-A962-62B6BF915CDE}" type="datetime3">
               <a:rPr lang="en-US" smtClean="0"/>
-              <a:t>24 June 2026</a:t>
+              <a:t>22 July 2026</a:t>
             </a:fld>
             <a:endParaRPr lang="en-US"/>
           </a:p>
@@ -15137,7 +15137,7 @@
           <a:p>
             <a:fld id="{B06F3EBE-B2E8-4992-9F00-9E4B44F057C0}" type="datetime3">
               <a:rPr lang="en-US" smtClean="0"/>
-              <a:t>24 June 2026</a:t>
+              <a:t>22 July 2026</a:t>
             </a:fld>
             <a:endParaRPr lang="en-US"/>
           </a:p>
@@ -15269,7 +15269,7 @@
           <a:p>
             <a:fld id="{D41656AB-D2E1-472E-8B95-0DF5C6E1D623}" type="datetime3">
               <a:rPr lang="en-US" smtClean="0"/>
-              <a:t>24 June 2026</a:t>
+              <a:t>22 July 2026</a:t>
             </a:fld>
             <a:endParaRPr lang="en-US"/>
           </a:p>
@@ -17154,7 +17154,7 @@
           <a:p>
             <a:fld id="{971AFA9C-17DA-4726-B9E3-ADECF7729AF7}" type="datetimeFigureOut">
               <a:rPr lang="en-US" smtClean="0"/>
-              <a:t>6/24/2026</a:t>
+              <a:t>7/22/2026</a:t>
             </a:fld>
             <a:endParaRPr lang="en-US"/>
           </a:p>
@@ -17465,7 +17465,7 @@
           <a:p>
             <a:fld id="{971AFA9C-17DA-4726-B9E3-ADECF7729AF7}" type="datetimeFigureOut">
               <a:rPr lang="en-US" smtClean="0"/>
-              <a:t>6/24/2026</a:t>
+              <a:t>7/22/2026</a:t>
             </a:fld>
             <a:endParaRPr lang="en-US"/>
           </a:p>
@@ -18382,7 +18382,7 @@
           <a:p>
             <a:fld id="{AD622D1A-DF83-41A8-85FF-04D90BF831D3}" type="datetime3">
               <a:rPr lang="en-US" smtClean="0"/>
-              <a:t>24 June 2026</a:t>
+              <a:t>22 July 2026</a:t>
             </a:fld>
             <a:endParaRPr lang="en-US"/>
           </a:p>
@@ -18632,7 +18632,7 @@
           <a:p>
             <a:fld id="{334F72C3-CDF3-44A8-B602-1649B1728485}" type="datetime3">
               <a:rPr lang="en-US" smtClean="0"/>
-              <a:t>24 June 2026</a:t>
+              <a:t>22 July 2026</a:t>
             </a:fld>
             <a:endParaRPr lang="en-US"/>
           </a:p>
@@ -18939,7 +18939,7 @@
           <a:p>
             <a:fld id="{1E0132BA-B5E7-4FFD-AF6C-169169D47D4A}" type="datetime3">
               <a:rPr lang="en-US" smtClean="0"/>
-              <a:t>24 June 2026</a:t>
+              <a:t>22 July 2026</a:t>
             </a:fld>
             <a:endParaRPr lang="en-US"/>
           </a:p>
@@ -19420,7 +19420,7 @@
           <a:p>
             <a:fld id="{81A30091-1C2A-4151-8D3C-D1E47A72615F}" type="datetime3">
               <a:rPr lang="en-US" smtClean="0"/>
-              <a:t>24 June 2026</a:t>
+              <a:t>22 July 2026</a:t>
             </a:fld>
             <a:endParaRPr lang="en-US"/>
           </a:p>
@@ -20057,7 +20057,7 @@
           <a:p>
             <a:fld id="{35D703CE-07B4-4C05-A488-B4566700621F}" type="datetime3">
               <a:rPr lang="en-US" smtClean="0"/>
-              <a:t>24 June 2026</a:t>
+              <a:t>22 July 2026</a:t>
             </a:fld>
             <a:endParaRPr lang="en-US"/>
           </a:p>
@@ -21115,7 +21115,7 @@
           <a:p>
             <a:fld id="{694BD61C-20BA-43AF-A21F-1DAFB3200099}" type="datetime3">
               <a:rPr lang="en-US" smtClean="0"/>
-              <a:t>24 June 2026</a:t>
+              <a:t>22 July 2026</a:t>
             </a:fld>
             <a:endParaRPr lang="en-US"/>
           </a:p>
@@ -21602,7 +21602,7 @@
           <a:p>
             <a:fld id="{CABCB1B0-B6E5-4DD1-BB55-95C076D6C0C8}" type="datetime3">
               <a:rPr lang="en-US" smtClean="0"/>
-              <a:t>24 June 2026</a:t>
+              <a:t>22 July 2026</a:t>
             </a:fld>
             <a:endParaRPr lang="en-US"/>
           </a:p>
@@ -22126,10 +22126,10 @@
       </p:grpSpPr>
       <p:sp>
         <p:nvSpPr>
-          <p:cNvPr id="27" name="Text Placeholder 26">
+          <p:cNvPr id="18" name="Text Placeholder 17">
             <a:extLst>
               <a:ext uri="{FF2B5EF4-FFF2-40B4-BE49-F238E27FC236}">
-                <a16:creationId xmlns:a16="http://schemas.microsoft.com/office/drawing/2014/main" id="{03AC4D28-436C-C3E8-E0B9-92B51D6A483B}"/>
+                <a16:creationId xmlns:a16="http://schemas.microsoft.com/office/drawing/2014/main" id="{736FF78A-67A5-A6F7-0C1D-28EC85EDE312}"/>
               </a:ext>
             </a:extLst>
           </p:cNvPr>
@@ -22151,10 +22151,10 @@
       </p:sp>
       <p:sp>
         <p:nvSpPr>
-          <p:cNvPr id="28" name="Text Placeholder 27">
+          <p:cNvPr id="19" name="Text Placeholder 18">
             <a:extLst>
               <a:ext uri="{FF2B5EF4-FFF2-40B4-BE49-F238E27FC236}">
-                <a16:creationId xmlns:a16="http://schemas.microsoft.com/office/drawing/2014/main" id="{A7B45948-3FA2-8289-3EAE-A20EDE2342A0}"/>
+                <a16:creationId xmlns:a16="http://schemas.microsoft.com/office/drawing/2014/main" id="{B3AA5713-CF04-6844-4ADF-D161378786FC}"/>
               </a:ext>
             </a:extLst>
           </p:cNvPr>
@@ -22176,10 +22176,10 @@
       </p:sp>
       <p:sp>
         <p:nvSpPr>
-          <p:cNvPr id="29" name="Text Placeholder 28">
+          <p:cNvPr id="20" name="Text Placeholder 19">
             <a:extLst>
               <a:ext uri="{FF2B5EF4-FFF2-40B4-BE49-F238E27FC236}">
-                <a16:creationId xmlns:a16="http://schemas.microsoft.com/office/drawing/2014/main" id="{7DCB2761-784F-FC85-1B92-A698C4A1CDD7}"/>
+                <a16:creationId xmlns:a16="http://schemas.microsoft.com/office/drawing/2014/main" id="{83DCC2A7-A048-983A-3CAF-4C9AFF506DAB}"/>
               </a:ext>
             </a:extLst>
           </p:cNvPr>
@@ -22201,10 +22201,10 @@
       </p:sp>
       <p:sp>
         <p:nvSpPr>
-          <p:cNvPr id="30" name="Text Placeholder 29">
+          <p:cNvPr id="21" name="Text Placeholder 20">
             <a:extLst>
               <a:ext uri="{FF2B5EF4-FFF2-40B4-BE49-F238E27FC236}">
-                <a16:creationId xmlns:a16="http://schemas.microsoft.com/office/drawing/2014/main" id="{10250C71-2431-B0BF-147C-14C4481825ED}"/>
+                <a16:creationId xmlns:a16="http://schemas.microsoft.com/office/drawing/2014/main" id="{8B5D128F-37DE-6374-3BE0-03701B6074E7}"/>
               </a:ext>
             </a:extLst>
           </p:cNvPr>
@@ -22226,10 +22226,10 @@
       </p:sp>
       <p:sp>
         <p:nvSpPr>
-          <p:cNvPr id="31" name="Text Placeholder 30">
+          <p:cNvPr id="22" name="Text Placeholder 21">
             <a:extLst>
               <a:ext uri="{FF2B5EF4-FFF2-40B4-BE49-F238E27FC236}">
-                <a16:creationId xmlns:a16="http://schemas.microsoft.com/office/drawing/2014/main" id="{7164429E-3598-7EC8-96B5-A205B260BAE1}"/>
+                <a16:creationId xmlns:a16="http://schemas.microsoft.com/office/drawing/2014/main" id="{83EB2394-1D9A-FE50-3153-D8024657CDC3}"/>
               </a:ext>
             </a:extLst>
           </p:cNvPr>
@@ -22251,10 +22251,10 @@
       </p:sp>
       <p:sp>
         <p:nvSpPr>
-          <p:cNvPr id="32" name="Text Placeholder 31">
+          <p:cNvPr id="23" name="Text Placeholder 22">
             <a:extLst>
               <a:ext uri="{FF2B5EF4-FFF2-40B4-BE49-F238E27FC236}">
-                <a16:creationId xmlns:a16="http://schemas.microsoft.com/office/drawing/2014/main" id="{5F0A8C28-8DFF-0BE4-4E6F-78C3DB802D17}"/>
+                <a16:creationId xmlns:a16="http://schemas.microsoft.com/office/drawing/2014/main" id="{29FFD31D-FFCF-E70C-A6A7-011414C6C14E}"/>
               </a:ext>
             </a:extLst>
           </p:cNvPr>
@@ -22276,10 +22276,10 @@
       </p:sp>
       <p:sp>
         <p:nvSpPr>
-          <p:cNvPr id="33" name="Text Placeholder 32">
+          <p:cNvPr id="24" name="Text Placeholder 23">
             <a:extLst>
               <a:ext uri="{FF2B5EF4-FFF2-40B4-BE49-F238E27FC236}">
-                <a16:creationId xmlns:a16="http://schemas.microsoft.com/office/drawing/2014/main" id="{40DA51FF-7403-41EC-CE28-89692499EFC6}"/>
+                <a16:creationId xmlns:a16="http://schemas.microsoft.com/office/drawing/2014/main" id="{A725870F-1F9D-A919-201D-04B2FA2C1B92}"/>
               </a:ext>
             </a:extLst>
           </p:cNvPr>
@@ -22295,16 +22295,16 @@
           <a:bodyPr/>
           <a:lstStyle/>
           <a:p>
-            <a:endParaRPr lang="en-US" dirty="0"/>
+            <a:endParaRPr lang="en-US"/>
           </a:p>
         </p:txBody>
       </p:sp>
       <p:sp>
         <p:nvSpPr>
-          <p:cNvPr id="34" name="Text Placeholder 33">
+          <p:cNvPr id="25" name="Text Placeholder 24">
             <a:extLst>
               <a:ext uri="{FF2B5EF4-FFF2-40B4-BE49-F238E27FC236}">
-                <a16:creationId xmlns:a16="http://schemas.microsoft.com/office/drawing/2014/main" id="{717B4346-4C78-DEEB-1565-BF4ABDA620BB}"/>
+                <a16:creationId xmlns:a16="http://schemas.microsoft.com/office/drawing/2014/main" id="{B5735AB8-ED92-B2FD-68CF-C5BBD058FF14}"/>
               </a:ext>
             </a:extLst>
           </p:cNvPr>
@@ -22326,10 +22326,10 @@
       </p:sp>
       <p:sp>
         <p:nvSpPr>
-          <p:cNvPr id="35" name="Text Placeholder 34">
+          <p:cNvPr id="37" name="Text Placeholder 36">
             <a:extLst>
               <a:ext uri="{FF2B5EF4-FFF2-40B4-BE49-F238E27FC236}">
-                <a16:creationId xmlns:a16="http://schemas.microsoft.com/office/drawing/2014/main" id="{1C037BC6-AD6B-478A-0C6C-E8CC009C52E5}"/>
+                <a16:creationId xmlns:a16="http://schemas.microsoft.com/office/drawing/2014/main" id="{877C4728-010C-8069-CEBF-1318BA8BDE3B}"/>
               </a:ext>
             </a:extLst>
           </p:cNvPr>
@@ -22351,10 +22351,10 @@
       </p:sp>
       <p:sp>
         <p:nvSpPr>
-          <p:cNvPr id="36" name="Text Placeholder 35">
+          <p:cNvPr id="38" name="Text Placeholder 37">
             <a:extLst>
               <a:ext uri="{FF2B5EF4-FFF2-40B4-BE49-F238E27FC236}">
-                <a16:creationId xmlns:a16="http://schemas.microsoft.com/office/drawing/2014/main" id="{96B531CF-FB17-BE4C-19ED-F992FE113E4E}"/>
+                <a16:creationId xmlns:a16="http://schemas.microsoft.com/office/drawing/2014/main" id="{8A6CCE46-1A09-1B1E-FE18-C7BE211450AD}"/>
               </a:ext>
             </a:extLst>
           </p:cNvPr>
@@ -22404,10 +22404,10 @@
       </p:sp>
       <p:sp>
         <p:nvSpPr>
-          <p:cNvPr id="26" name="Subtitle 25">
+          <p:cNvPr id="17" name="Subtitle 16">
             <a:extLst>
               <a:ext uri="{FF2B5EF4-FFF2-40B4-BE49-F238E27FC236}">
-                <a16:creationId xmlns:a16="http://schemas.microsoft.com/office/drawing/2014/main" id="{B49BAAE9-60E3-7F9D-E6F3-4455C3037AD8}"/>
+                <a16:creationId xmlns:a16="http://schemas.microsoft.com/office/drawing/2014/main" id="{85650F60-7579-0C30-659C-AA77FC1BB997}"/>
               </a:ext>
             </a:extLst>
           </p:cNvPr>
@@ -22423,7 +22423,7 @@
           <a:bodyPr/>
           <a:lstStyle/>
           <a:p>
-            <a:endParaRPr lang="en-US" dirty="0"/>
+            <a:endParaRPr lang="en-US"/>
           </a:p>
         </p:txBody>
       </p:sp>
@@ -22528,7 +22528,7 @@
         <p:spPr>
           <a:xfrm>
             <a:off x="777240" y="1443841"/>
-            <a:ext cx="6097604" cy="646331"/>
+            <a:ext cx="9307994" cy="646331"/>
           </a:xfrm>
           <a:prstGeom prst="rect">
             <a:avLst/>
@@ -22542,16 +22542,25 @@
           <a:lstStyle/>
           <a:p>
             <a:r>
-              <a:rPr lang="en-US" dirty="0" err="1"/>
+              <a:rPr lang="en-US" dirty="0" err="1">
+                <a:latin typeface="Courier New" panose="02070309020205020404" pitchFamily="49" charset="0"/>
+                <a:cs typeface="Courier New" panose="02070309020205020404" pitchFamily="49" charset="0"/>
+              </a:rPr>
               <a:t>my_list</a:t>
             </a:r>
             <a:r>
-              <a:rPr lang="en-US" dirty="0"/>
+              <a:rPr lang="en-US" dirty="0">
+                <a:latin typeface="Courier New" panose="02070309020205020404" pitchFamily="49" charset="0"/>
+                <a:cs typeface="Courier New" panose="02070309020205020404" pitchFamily="49" charset="0"/>
+              </a:rPr>
               <a:t> = [1, 2, 3]</a:t>
             </a:r>
           </a:p>
           <a:p>
-            <a:endParaRPr lang="en-US" dirty="0"/>
+            <a:endParaRPr lang="en-US" dirty="0">
+              <a:latin typeface="Courier New" panose="02070309020205020404" pitchFamily="49" charset="0"/>
+              <a:cs typeface="Courier New" panose="02070309020205020404" pitchFamily="49" charset="0"/>
+            </a:endParaRPr>
           </a:p>
         </p:txBody>
       </p:sp>
@@ -22570,7 +22579,7 @@
         <p:spPr>
           <a:xfrm>
             <a:off x="777239" y="2090172"/>
-            <a:ext cx="6624587" cy="923330"/>
+            <a:ext cx="10112434" cy="923330"/>
           </a:xfrm>
           <a:prstGeom prst="rect">
             <a:avLst/>
@@ -22584,26 +22593,41 @@
           <a:lstStyle/>
           <a:p>
             <a:r>
-              <a:rPr lang="en-US" dirty="0"/>
+              <a:rPr lang="en-US" dirty="0">
+                <a:latin typeface="Courier New" panose="02070309020205020404" pitchFamily="49" charset="0"/>
+                <a:cs typeface="Courier New" panose="02070309020205020404" pitchFamily="49" charset="0"/>
+              </a:rPr>
               <a:t># Slice copy</a:t>
             </a:r>
           </a:p>
           <a:p>
             <a:r>
-              <a:rPr lang="en-US" dirty="0"/>
+              <a:rPr lang="en-US" dirty="0">
+                <a:latin typeface="Courier New" panose="02070309020205020404" pitchFamily="49" charset="0"/>
+                <a:cs typeface="Courier New" panose="02070309020205020404" pitchFamily="49" charset="0"/>
+              </a:rPr>
               <a:t>copy = </a:t>
             </a:r>
             <a:r>
-              <a:rPr lang="en-US" dirty="0" err="1"/>
+              <a:rPr lang="en-US" dirty="0" err="1">
+                <a:latin typeface="Courier New" panose="02070309020205020404" pitchFamily="49" charset="0"/>
+                <a:cs typeface="Courier New" panose="02070309020205020404" pitchFamily="49" charset="0"/>
+              </a:rPr>
               <a:t>my_list</a:t>
             </a:r>
             <a:r>
-              <a:rPr lang="en-US" dirty="0"/>
+              <a:rPr lang="en-US" dirty="0">
+                <a:latin typeface="Courier New" panose="02070309020205020404" pitchFamily="49" charset="0"/>
+                <a:cs typeface="Courier New" panose="02070309020205020404" pitchFamily="49" charset="0"/>
+              </a:rPr>
               <a:t>[:]</a:t>
             </a:r>
           </a:p>
           <a:p>
-            <a:endParaRPr lang="en-US" dirty="0"/>
+            <a:endParaRPr lang="en-US" dirty="0">
+              <a:latin typeface="Courier New" panose="02070309020205020404" pitchFamily="49" charset="0"/>
+              <a:cs typeface="Courier New" panose="02070309020205020404" pitchFamily="49" charset="0"/>
+            </a:endParaRPr>
           </a:p>
         </p:txBody>
       </p:sp>
@@ -22622,7 +22646,7 @@
         <p:spPr>
           <a:xfrm>
             <a:off x="777239" y="3143640"/>
-            <a:ext cx="6097604" cy="923330"/>
+            <a:ext cx="9307994" cy="923330"/>
           </a:xfrm>
           <a:prstGeom prst="rect">
             <a:avLst/>
@@ -22636,26 +22660,41 @@
           <a:lstStyle/>
           <a:p>
             <a:r>
-              <a:rPr lang="en-US" dirty="0"/>
+              <a:rPr lang="en-US" dirty="0">
+                <a:latin typeface="Courier New" panose="02070309020205020404" pitchFamily="49" charset="0"/>
+                <a:cs typeface="Courier New" panose="02070309020205020404" pitchFamily="49" charset="0"/>
+              </a:rPr>
               <a:t># .copy() method</a:t>
             </a:r>
           </a:p>
           <a:p>
             <a:r>
-              <a:rPr lang="en-US" dirty="0"/>
+              <a:rPr lang="en-US" dirty="0">
+                <a:latin typeface="Courier New" panose="02070309020205020404" pitchFamily="49" charset="0"/>
+                <a:cs typeface="Courier New" panose="02070309020205020404" pitchFamily="49" charset="0"/>
+              </a:rPr>
               <a:t>copy = </a:t>
             </a:r>
             <a:r>
-              <a:rPr lang="en-US" dirty="0" err="1"/>
+              <a:rPr lang="en-US" dirty="0" err="1">
+                <a:latin typeface="Courier New" panose="02070309020205020404" pitchFamily="49" charset="0"/>
+                <a:cs typeface="Courier New" panose="02070309020205020404" pitchFamily="49" charset="0"/>
+              </a:rPr>
               <a:t>my_list.copy</a:t>
             </a:r>
             <a:r>
-              <a:rPr lang="en-US" dirty="0"/>
+              <a:rPr lang="en-US" dirty="0">
+                <a:latin typeface="Courier New" panose="02070309020205020404" pitchFamily="49" charset="0"/>
+                <a:cs typeface="Courier New" panose="02070309020205020404" pitchFamily="49" charset="0"/>
+              </a:rPr>
               <a:t>()</a:t>
             </a:r>
           </a:p>
           <a:p>
-            <a:endParaRPr lang="en-US" dirty="0"/>
+            <a:endParaRPr lang="en-US" dirty="0">
+              <a:latin typeface="Courier New" panose="02070309020205020404" pitchFamily="49" charset="0"/>
+              <a:cs typeface="Courier New" panose="02070309020205020404" pitchFamily="49" charset="0"/>
+            </a:endParaRPr>
           </a:p>
         </p:txBody>
       </p:sp>
@@ -22674,7 +22713,7 @@
         <p:spPr>
           <a:xfrm>
             <a:off x="777239" y="4264128"/>
-            <a:ext cx="6097604" cy="646331"/>
+            <a:ext cx="9307994" cy="646331"/>
           </a:xfrm>
           <a:prstGeom prst="rect">
             <a:avLst/>
@@ -22688,21 +22727,33 @@
           <a:lstStyle/>
           <a:p>
             <a:r>
-              <a:rPr lang="en-US" dirty="0"/>
+              <a:rPr lang="en-US" dirty="0">
+                <a:latin typeface="Courier New" panose="02070309020205020404" pitchFamily="49" charset="0"/>
+                <a:cs typeface="Courier New" panose="02070309020205020404" pitchFamily="49" charset="0"/>
+              </a:rPr>
               <a:t># list() constructor</a:t>
             </a:r>
           </a:p>
           <a:p>
             <a:r>
-              <a:rPr lang="en-US" dirty="0"/>
+              <a:rPr lang="en-US" dirty="0">
+                <a:latin typeface="Courier New" panose="02070309020205020404" pitchFamily="49" charset="0"/>
+                <a:cs typeface="Courier New" panose="02070309020205020404" pitchFamily="49" charset="0"/>
+              </a:rPr>
               <a:t>copy = list(</a:t>
             </a:r>
             <a:r>
-              <a:rPr lang="en-US" dirty="0" err="1"/>
+              <a:rPr lang="en-US" dirty="0" err="1">
+                <a:latin typeface="Courier New" panose="02070309020205020404" pitchFamily="49" charset="0"/>
+                <a:cs typeface="Courier New" panose="02070309020205020404" pitchFamily="49" charset="0"/>
+              </a:rPr>
               <a:t>my_list</a:t>
             </a:r>
             <a:r>
-              <a:rPr lang="en-US" dirty="0"/>
+              <a:rPr lang="en-US" dirty="0">
+                <a:latin typeface="Courier New" panose="02070309020205020404" pitchFamily="49" charset="0"/>
+                <a:cs typeface="Courier New" panose="02070309020205020404" pitchFamily="49" charset="0"/>
+              </a:rPr>
               <a:t>)</a:t>
             </a:r>
           </a:p>
@@ -22723,7 +22774,7 @@
         <p:spPr>
           <a:xfrm>
             <a:off x="777239" y="4982488"/>
-            <a:ext cx="6097604" cy="1200329"/>
+            <a:ext cx="9307994" cy="1200329"/>
           </a:xfrm>
           <a:prstGeom prst="rect">
             <a:avLst/>
@@ -22736,39 +22787,63 @@
           </a:bodyPr>
           <a:lstStyle/>
           <a:p>
-            <a:endParaRPr lang="en-US" dirty="0"/>
-          </a:p>
-          <a:p>
-            <a:r>
-              <a:rPr lang="en-US" dirty="0"/>
+            <a:endParaRPr lang="en-US" dirty="0">
+              <a:latin typeface="Courier New" panose="02070309020205020404" pitchFamily="49" charset="0"/>
+              <a:cs typeface="Courier New" panose="02070309020205020404" pitchFamily="49" charset="0"/>
+            </a:endParaRPr>
+          </a:p>
+          <a:p>
+            <a:r>
+              <a:rPr lang="en-US" dirty="0">
+                <a:latin typeface="Courier New" panose="02070309020205020404" pitchFamily="49" charset="0"/>
+                <a:cs typeface="Courier New" panose="02070309020205020404" pitchFamily="49" charset="0"/>
+              </a:rPr>
               <a:t># Deep copy (use when list contains nested lists)</a:t>
             </a:r>
           </a:p>
           <a:p>
             <a:r>
-              <a:rPr lang="en-US" dirty="0"/>
+              <a:rPr lang="en-US" dirty="0">
+                <a:latin typeface="Courier New" panose="02070309020205020404" pitchFamily="49" charset="0"/>
+                <a:cs typeface="Courier New" panose="02070309020205020404" pitchFamily="49" charset="0"/>
+              </a:rPr>
               <a:t>import copy</a:t>
             </a:r>
           </a:p>
           <a:p>
             <a:r>
-              <a:rPr lang="en-US" dirty="0"/>
+              <a:rPr lang="en-US" dirty="0">
+                <a:latin typeface="Courier New" panose="02070309020205020404" pitchFamily="49" charset="0"/>
+                <a:cs typeface="Courier New" panose="02070309020205020404" pitchFamily="49" charset="0"/>
+              </a:rPr>
               <a:t>copy = </a:t>
             </a:r>
             <a:r>
-              <a:rPr lang="en-US" dirty="0" err="1"/>
+              <a:rPr lang="en-US" dirty="0" err="1">
+                <a:latin typeface="Courier New" panose="02070309020205020404" pitchFamily="49" charset="0"/>
+                <a:cs typeface="Courier New" panose="02070309020205020404" pitchFamily="49" charset="0"/>
+              </a:rPr>
               <a:t>copy.deepcopy</a:t>
             </a:r>
             <a:r>
-              <a:rPr lang="en-US" dirty="0"/>
+              <a:rPr lang="en-US" dirty="0">
+                <a:latin typeface="Courier New" panose="02070309020205020404" pitchFamily="49" charset="0"/>
+                <a:cs typeface="Courier New" panose="02070309020205020404" pitchFamily="49" charset="0"/>
+              </a:rPr>
               <a:t>(</a:t>
             </a:r>
             <a:r>
-              <a:rPr lang="en-US" dirty="0" err="1"/>
+              <a:rPr lang="en-US" dirty="0" err="1">
+                <a:latin typeface="Courier New" panose="02070309020205020404" pitchFamily="49" charset="0"/>
+                <a:cs typeface="Courier New" panose="02070309020205020404" pitchFamily="49" charset="0"/>
+              </a:rPr>
               <a:t>my_list</a:t>
             </a:r>
             <a:r>
-              <a:rPr lang="en-US" dirty="0"/>
+              <a:rPr lang="en-US" dirty="0">
+                <a:latin typeface="Courier New" panose="02070309020205020404" pitchFamily="49" charset="0"/>
+                <a:cs typeface="Courier New" panose="02070309020205020404" pitchFamily="49" charset="0"/>
+              </a:rPr>
               <a:t>)</a:t>
             </a:r>
           </a:p>
@@ -23083,53 +23158,89 @@
           <a:lstStyle/>
           <a:p>
             <a:r>
-              <a:rPr lang="en-US" sz="2800" dirty="0" err="1"/>
+              <a:rPr lang="en-US" sz="2800" dirty="0" err="1">
+                <a:latin typeface="Courier New" panose="02070309020205020404" pitchFamily="49" charset="0"/>
+                <a:cs typeface="Courier New" panose="02070309020205020404" pitchFamily="49" charset="0"/>
+              </a:rPr>
               <a:t>my_list</a:t>
             </a:r>
             <a:r>
-              <a:rPr lang="en-US" sz="2800" dirty="0"/>
+              <a:rPr lang="en-US" sz="2800" dirty="0">
+                <a:latin typeface="Courier New" panose="02070309020205020404" pitchFamily="49" charset="0"/>
+                <a:cs typeface="Courier New" panose="02070309020205020404" pitchFamily="49" charset="0"/>
+              </a:rPr>
               <a:t> = [1, 2, 3]</a:t>
             </a:r>
           </a:p>
           <a:p>
             <a:r>
-              <a:rPr lang="en-US" sz="2800" dirty="0" err="1"/>
+              <a:rPr lang="en-US" sz="2800" dirty="0" err="1">
+                <a:latin typeface="Courier New" panose="02070309020205020404" pitchFamily="49" charset="0"/>
+                <a:cs typeface="Courier New" panose="02070309020205020404" pitchFamily="49" charset="0"/>
+              </a:rPr>
               <a:t>second_list</a:t>
             </a:r>
             <a:r>
-              <a:rPr lang="en-US" sz="2800" dirty="0"/>
+              <a:rPr lang="en-US" sz="2800" dirty="0">
+                <a:latin typeface="Courier New" panose="02070309020205020404" pitchFamily="49" charset="0"/>
+                <a:cs typeface="Courier New" panose="02070309020205020404" pitchFamily="49" charset="0"/>
+              </a:rPr>
               <a:t> = </a:t>
             </a:r>
             <a:r>
-              <a:rPr lang="en-US" sz="2800" dirty="0" err="1"/>
+              <a:rPr lang="en-US" sz="2800" dirty="0" err="1">
+                <a:latin typeface="Courier New" panose="02070309020205020404" pitchFamily="49" charset="0"/>
+                <a:cs typeface="Courier New" panose="02070309020205020404" pitchFamily="49" charset="0"/>
+              </a:rPr>
               <a:t>my_list</a:t>
             </a:r>
-            <a:endParaRPr lang="en-US" sz="2800" dirty="0"/>
-          </a:p>
-          <a:p>
-            <a:endParaRPr lang="en-US" sz="2800" dirty="0"/>
-          </a:p>
-          <a:p>
-            <a:r>
-              <a:rPr lang="en-US" sz="2800" dirty="0" err="1"/>
+            <a:endParaRPr lang="en-US" sz="2800" dirty="0">
+              <a:latin typeface="Courier New" panose="02070309020205020404" pitchFamily="49" charset="0"/>
+              <a:cs typeface="Courier New" panose="02070309020205020404" pitchFamily="49" charset="0"/>
+            </a:endParaRPr>
+          </a:p>
+          <a:p>
+            <a:endParaRPr lang="en-US" sz="2800" dirty="0">
+              <a:latin typeface="Courier New" panose="02070309020205020404" pitchFamily="49" charset="0"/>
+              <a:cs typeface="Courier New" panose="02070309020205020404" pitchFamily="49" charset="0"/>
+            </a:endParaRPr>
+          </a:p>
+          <a:p>
+            <a:r>
+              <a:rPr lang="en-US" sz="2800" dirty="0" err="1">
+                <a:latin typeface="Courier New" panose="02070309020205020404" pitchFamily="49" charset="0"/>
+                <a:cs typeface="Courier New" panose="02070309020205020404" pitchFamily="49" charset="0"/>
+              </a:rPr>
               <a:t>second_list</a:t>
             </a:r>
             <a:r>
-              <a:rPr lang="en-US" sz="2800" dirty="0"/>
+              <a:rPr lang="en-US" sz="2800" dirty="0">
+                <a:latin typeface="Courier New" panose="02070309020205020404" pitchFamily="49" charset="0"/>
+                <a:cs typeface="Courier New" panose="02070309020205020404" pitchFamily="49" charset="0"/>
+              </a:rPr>
               <a:t>[0] = 100</a:t>
             </a:r>
           </a:p>
           <a:p>
             <a:r>
-              <a:rPr lang="en-US" sz="2800" dirty="0"/>
+              <a:rPr lang="en-US" sz="2800" dirty="0">
+                <a:latin typeface="Courier New" panose="02070309020205020404" pitchFamily="49" charset="0"/>
+                <a:cs typeface="Courier New" panose="02070309020205020404" pitchFamily="49" charset="0"/>
+              </a:rPr>
               <a:t>print(</a:t>
             </a:r>
             <a:r>
-              <a:rPr lang="en-US" sz="2800" dirty="0" err="1"/>
+              <a:rPr lang="en-US" sz="2800" dirty="0" err="1">
+                <a:latin typeface="Courier New" panose="02070309020205020404" pitchFamily="49" charset="0"/>
+                <a:cs typeface="Courier New" panose="02070309020205020404" pitchFamily="49" charset="0"/>
+              </a:rPr>
               <a:t>my_list</a:t>
             </a:r>
             <a:r>
-              <a:rPr lang="en-US" sz="2800" dirty="0"/>
+              <a:rPr lang="en-US" sz="2800" dirty="0">
+                <a:latin typeface="Courier New" panose="02070309020205020404" pitchFamily="49" charset="0"/>
+                <a:cs typeface="Courier New" panose="02070309020205020404" pitchFamily="49" charset="0"/>
+              </a:rPr>
               <a:t>)</a:t>
             </a:r>
           </a:p>
@@ -24695,7 +24806,7 @@
         <p:spPr>
           <a:xfrm>
             <a:off x="548640" y="1223451"/>
-            <a:ext cx="6097604" cy="1200329"/>
+            <a:ext cx="10611196" cy="1200329"/>
           </a:xfrm>
           <a:prstGeom prst="rect">
             <a:avLst/>
@@ -24709,32 +24820,50 @@
           <a:lstStyle/>
           <a:p>
             <a:r>
-              <a:rPr lang="en-US" dirty="0"/>
+              <a:rPr lang="en-US" dirty="0">
+                <a:latin typeface="Courier New" panose="02070309020205020404" pitchFamily="49" charset="0"/>
+                <a:cs typeface="Courier New" panose="02070309020205020404" pitchFamily="49" charset="0"/>
+              </a:rPr>
               <a:t># Empty tuple</a:t>
             </a:r>
           </a:p>
           <a:p>
             <a:r>
-              <a:rPr lang="en-US" dirty="0" err="1"/>
+              <a:rPr lang="en-US" dirty="0" err="1">
+                <a:latin typeface="Courier New" panose="02070309020205020404" pitchFamily="49" charset="0"/>
+                <a:cs typeface="Courier New" panose="02070309020205020404" pitchFamily="49" charset="0"/>
+              </a:rPr>
               <a:t>my_tuple</a:t>
             </a:r>
             <a:r>
-              <a:rPr lang="en-US" dirty="0"/>
+              <a:rPr lang="en-US" dirty="0">
+                <a:latin typeface="Courier New" panose="02070309020205020404" pitchFamily="49" charset="0"/>
+                <a:cs typeface="Courier New" panose="02070309020205020404" pitchFamily="49" charset="0"/>
+              </a:rPr>
               <a:t> = ()</a:t>
             </a:r>
           </a:p>
           <a:p>
             <a:r>
-              <a:rPr lang="en-US" dirty="0" err="1"/>
+              <a:rPr lang="en-US" dirty="0" err="1">
+                <a:latin typeface="Courier New" panose="02070309020205020404" pitchFamily="49" charset="0"/>
+                <a:cs typeface="Courier New" panose="02070309020205020404" pitchFamily="49" charset="0"/>
+              </a:rPr>
               <a:t>my_tuple</a:t>
             </a:r>
             <a:r>
-              <a:rPr lang="en-US" dirty="0"/>
+              <a:rPr lang="en-US" dirty="0">
+                <a:latin typeface="Courier New" panose="02070309020205020404" pitchFamily="49" charset="0"/>
+                <a:cs typeface="Courier New" panose="02070309020205020404" pitchFamily="49" charset="0"/>
+              </a:rPr>
               <a:t> = tuple()</a:t>
             </a:r>
           </a:p>
           <a:p>
-            <a:endParaRPr lang="en-US" dirty="0"/>
+            <a:endParaRPr lang="en-US" dirty="0">
+              <a:latin typeface="Courier New" panose="02070309020205020404" pitchFamily="49" charset="0"/>
+              <a:cs typeface="Courier New" panose="02070309020205020404" pitchFamily="49" charset="0"/>
+            </a:endParaRPr>
           </a:p>
         </p:txBody>
       </p:sp>
@@ -24753,7 +24882,7 @@
         <p:spPr>
           <a:xfrm>
             <a:off x="548640" y="2423780"/>
-            <a:ext cx="6097604" cy="923330"/>
+            <a:ext cx="10611196" cy="923330"/>
           </a:xfrm>
           <a:prstGeom prst="rect">
             <a:avLst/>
@@ -24767,22 +24896,34 @@
           <a:lstStyle/>
           <a:p>
             <a:r>
-              <a:rPr lang="en-US" dirty="0"/>
+              <a:rPr lang="en-US" dirty="0">
+                <a:latin typeface="Courier New" panose="02070309020205020404" pitchFamily="49" charset="0"/>
+                <a:cs typeface="Courier New" panose="02070309020205020404" pitchFamily="49" charset="0"/>
+              </a:rPr>
               <a:t># With values</a:t>
             </a:r>
           </a:p>
           <a:p>
             <a:r>
-              <a:rPr lang="en-US" dirty="0" err="1"/>
+              <a:rPr lang="en-US" dirty="0" err="1">
+                <a:latin typeface="Courier New" panose="02070309020205020404" pitchFamily="49" charset="0"/>
+                <a:cs typeface="Courier New" panose="02070309020205020404" pitchFamily="49" charset="0"/>
+              </a:rPr>
               <a:t>my_tuple</a:t>
             </a:r>
             <a:r>
-              <a:rPr lang="en-US" dirty="0"/>
+              <a:rPr lang="en-US" dirty="0">
+                <a:latin typeface="Courier New" panose="02070309020205020404" pitchFamily="49" charset="0"/>
+                <a:cs typeface="Courier New" panose="02070309020205020404" pitchFamily="49" charset="0"/>
+              </a:rPr>
               <a:t> = (1, 2, 3)</a:t>
             </a:r>
           </a:p>
           <a:p>
-            <a:endParaRPr lang="en-US" dirty="0"/>
+            <a:endParaRPr lang="en-US" dirty="0">
+              <a:latin typeface="Courier New" panose="02070309020205020404" pitchFamily="49" charset="0"/>
+              <a:cs typeface="Courier New" panose="02070309020205020404" pitchFamily="49" charset="0"/>
+            </a:endParaRPr>
           </a:p>
         </p:txBody>
       </p:sp>
@@ -24801,7 +24942,7 @@
         <p:spPr>
           <a:xfrm>
             <a:off x="548640" y="3374382"/>
-            <a:ext cx="6097604" cy="923330"/>
+            <a:ext cx="10611196" cy="923330"/>
           </a:xfrm>
           <a:prstGeom prst="rect">
             <a:avLst/>
@@ -24815,22 +24956,34 @@
           <a:lstStyle/>
           <a:p>
             <a:r>
-              <a:rPr lang="en-US" dirty="0"/>
+              <a:rPr lang="en-US" dirty="0">
+                <a:latin typeface="Courier New" panose="02070309020205020404" pitchFamily="49" charset="0"/>
+                <a:cs typeface="Courier New" panose="02070309020205020404" pitchFamily="49" charset="0"/>
+              </a:rPr>
               <a:t># Parentheses are actually optional</a:t>
             </a:r>
           </a:p>
           <a:p>
             <a:r>
-              <a:rPr lang="en-US" dirty="0" err="1"/>
+              <a:rPr lang="en-US" dirty="0" err="1">
+                <a:latin typeface="Courier New" panose="02070309020205020404" pitchFamily="49" charset="0"/>
+                <a:cs typeface="Courier New" panose="02070309020205020404" pitchFamily="49" charset="0"/>
+              </a:rPr>
               <a:t>my_tuple</a:t>
             </a:r>
             <a:r>
-              <a:rPr lang="en-US" dirty="0"/>
+              <a:rPr lang="en-US" dirty="0">
+                <a:latin typeface="Courier New" panose="02070309020205020404" pitchFamily="49" charset="0"/>
+                <a:cs typeface="Courier New" panose="02070309020205020404" pitchFamily="49" charset="0"/>
+              </a:rPr>
               <a:t> = 1, 2, 3             # (1, 2, 3)</a:t>
             </a:r>
           </a:p>
           <a:p>
-            <a:endParaRPr lang="en-US" dirty="0"/>
+            <a:endParaRPr lang="en-US" dirty="0">
+              <a:latin typeface="Courier New" panose="02070309020205020404" pitchFamily="49" charset="0"/>
+              <a:cs typeface="Courier New" panose="02070309020205020404" pitchFamily="49" charset="0"/>
+            </a:endParaRPr>
           </a:p>
         </p:txBody>
       </p:sp>
@@ -24849,7 +25002,7 @@
         <p:spPr>
           <a:xfrm>
             <a:off x="548640" y="4158279"/>
-            <a:ext cx="6097604" cy="1200329"/>
+            <a:ext cx="10611196" cy="1200329"/>
           </a:xfrm>
           <a:prstGeom prst="rect">
             <a:avLst/>
@@ -24863,32 +25016,50 @@
           <a:lstStyle/>
           <a:p>
             <a:r>
-              <a:rPr lang="en-US" dirty="0"/>
+              <a:rPr lang="en-US" dirty="0">
+                <a:latin typeface="Courier New" panose="02070309020205020404" pitchFamily="49" charset="0"/>
+                <a:cs typeface="Courier New" panose="02070309020205020404" pitchFamily="49" charset="0"/>
+              </a:rPr>
               <a:t># Single item (trailing comma is required!)</a:t>
             </a:r>
           </a:p>
           <a:p>
             <a:r>
-              <a:rPr lang="en-US" dirty="0" err="1"/>
+              <a:rPr lang="en-US" dirty="0" err="1">
+                <a:latin typeface="Courier New" panose="02070309020205020404" pitchFamily="49" charset="0"/>
+                <a:cs typeface="Courier New" panose="02070309020205020404" pitchFamily="49" charset="0"/>
+              </a:rPr>
               <a:t>my_tuple</a:t>
             </a:r>
             <a:r>
-              <a:rPr lang="en-US" dirty="0"/>
+              <a:rPr lang="en-US" dirty="0">
+                <a:latin typeface="Courier New" panose="02070309020205020404" pitchFamily="49" charset="0"/>
+                <a:cs typeface="Courier New" panose="02070309020205020404" pitchFamily="49" charset="0"/>
+              </a:rPr>
               <a:t> = (5,)                # (5,)  ✅</a:t>
             </a:r>
           </a:p>
           <a:p>
             <a:r>
-              <a:rPr lang="en-US" dirty="0" err="1"/>
+              <a:rPr lang="en-US" dirty="0" err="1">
+                <a:latin typeface="Courier New" panose="02070309020205020404" pitchFamily="49" charset="0"/>
+                <a:cs typeface="Courier New" panose="02070309020205020404" pitchFamily="49" charset="0"/>
+              </a:rPr>
               <a:t>my_tuple</a:t>
             </a:r>
             <a:r>
-              <a:rPr lang="en-US" dirty="0"/>
+              <a:rPr lang="en-US" dirty="0">
+                <a:latin typeface="Courier New" panose="02070309020205020404" pitchFamily="49" charset="0"/>
+                <a:cs typeface="Courier New" panose="02070309020205020404" pitchFamily="49" charset="0"/>
+              </a:rPr>
               <a:t> = (5)                 # 5     ❌ this is just an integer</a:t>
             </a:r>
           </a:p>
           <a:p>
-            <a:endParaRPr lang="en-US" dirty="0"/>
+            <a:endParaRPr lang="en-US" dirty="0">
+              <a:latin typeface="Courier New" panose="02070309020205020404" pitchFamily="49" charset="0"/>
+              <a:cs typeface="Courier New" panose="02070309020205020404" pitchFamily="49" charset="0"/>
+            </a:endParaRPr>
           </a:p>
         </p:txBody>
       </p:sp>
@@ -24907,7 +25078,7 @@
         <p:spPr>
           <a:xfrm>
             <a:off x="548640" y="5279333"/>
-            <a:ext cx="6097604" cy="1200329"/>
+            <a:ext cx="10611196" cy="1200329"/>
           </a:xfrm>
           <a:prstGeom prst="rect">
             <a:avLst/>
@@ -24921,42 +25092,69 @@
           <a:lstStyle/>
           <a:p>
             <a:r>
-              <a:rPr lang="en-US" dirty="0"/>
+              <a:rPr lang="en-US" dirty="0">
+                <a:latin typeface="Courier New" panose="02070309020205020404" pitchFamily="49" charset="0"/>
+                <a:cs typeface="Courier New" panose="02070309020205020404" pitchFamily="49" charset="0"/>
+              </a:rPr>
               <a:t># From another </a:t>
             </a:r>
             <a:r>
-              <a:rPr lang="en-US" dirty="0" err="1"/>
+              <a:rPr lang="en-US" dirty="0" err="1">
+                <a:latin typeface="Courier New" panose="02070309020205020404" pitchFamily="49" charset="0"/>
+                <a:cs typeface="Courier New" panose="02070309020205020404" pitchFamily="49" charset="0"/>
+              </a:rPr>
               <a:t>iterable</a:t>
             </a:r>
-            <a:endParaRPr lang="en-US" dirty="0"/>
-          </a:p>
-          <a:p>
-            <a:r>
-              <a:rPr lang="en-US" dirty="0" err="1"/>
+            <a:endParaRPr lang="en-US" dirty="0">
+              <a:latin typeface="Courier New" panose="02070309020205020404" pitchFamily="49" charset="0"/>
+              <a:cs typeface="Courier New" panose="02070309020205020404" pitchFamily="49" charset="0"/>
+            </a:endParaRPr>
+          </a:p>
+          <a:p>
+            <a:r>
+              <a:rPr lang="en-US" dirty="0" err="1">
+                <a:latin typeface="Courier New" panose="02070309020205020404" pitchFamily="49" charset="0"/>
+                <a:cs typeface="Courier New" panose="02070309020205020404" pitchFamily="49" charset="0"/>
+              </a:rPr>
               <a:t>my_tuple</a:t>
             </a:r>
             <a:r>
-              <a:rPr lang="en-US" dirty="0"/>
+              <a:rPr lang="en-US" dirty="0">
+                <a:latin typeface="Courier New" panose="02070309020205020404" pitchFamily="49" charset="0"/>
+                <a:cs typeface="Courier New" panose="02070309020205020404" pitchFamily="49" charset="0"/>
+              </a:rPr>
               <a:t> = tuple("hello")      # ('h', 'e', 'l', 'l', 'o')</a:t>
             </a:r>
           </a:p>
           <a:p>
             <a:r>
-              <a:rPr lang="en-US" dirty="0" err="1"/>
+              <a:rPr lang="en-US" dirty="0" err="1">
+                <a:latin typeface="Courier New" panose="02070309020205020404" pitchFamily="49" charset="0"/>
+                <a:cs typeface="Courier New" panose="02070309020205020404" pitchFamily="49" charset="0"/>
+              </a:rPr>
               <a:t>my_tuple</a:t>
             </a:r>
             <a:r>
-              <a:rPr lang="en-US" dirty="0"/>
+              <a:rPr lang="en-US" dirty="0">
+                <a:latin typeface="Courier New" panose="02070309020205020404" pitchFamily="49" charset="0"/>
+                <a:cs typeface="Courier New" panose="02070309020205020404" pitchFamily="49" charset="0"/>
+              </a:rPr>
               <a:t> = tuple([1, 2, 3])    # (1, 2, 3)  (from a list)</a:t>
             </a:r>
           </a:p>
           <a:p>
             <a:r>
-              <a:rPr lang="en-US" dirty="0" err="1"/>
+              <a:rPr lang="en-US" dirty="0" err="1">
+                <a:latin typeface="Courier New" panose="02070309020205020404" pitchFamily="49" charset="0"/>
+                <a:cs typeface="Courier New" panose="02070309020205020404" pitchFamily="49" charset="0"/>
+              </a:rPr>
               <a:t>my_tuple</a:t>
             </a:r>
             <a:r>
-              <a:rPr lang="en-US" dirty="0"/>
+              <a:rPr lang="en-US" dirty="0">
+                <a:latin typeface="Courier New" panose="02070309020205020404" pitchFamily="49" charset="0"/>
+                <a:cs typeface="Courier New" panose="02070309020205020404" pitchFamily="49" charset="0"/>
+              </a:rPr>
               <a:t> = tuple(range(5))     # (0, 1, 2, 3, 4)</a:t>
             </a:r>
           </a:p>
@@ -25238,7 +25436,7 @@
 </file>
 
 <file path=ppt/slides/slide14.xml><?xml version="1.0" encoding="utf-8"?>
-<p:sld xmlns:a="http://schemas.openxmlformats.org/drawingml/2006/main" xmlns:r="http://schemas.openxmlformats.org/officeDocument/2006/relationships" xmlns:p="http://schemas.openxmlformats.org/presentationml/2006/main">
+<p:sld xmlns:a="http://schemas.openxmlformats.org/drawingml/2006/main" xmlns:r="http://schemas.openxmlformats.org/officeDocument/2006/relationships" xmlns:p="http://schemas.openxmlformats.org/presentationml/2006/main" show="0">
   <p:cSld>
     <p:spTree>
       <p:nvGrpSpPr>
@@ -25276,12 +25474,7 @@
             <p:ph type="title"/>
           </p:nvPr>
         </p:nvSpPr>
-        <p:spPr>
-          <a:xfrm>
-            <a:off x="549275" y="388461"/>
-            <a:ext cx="8231293" cy="1189037"/>
-          </a:xfrm>
-        </p:spPr>
+        <p:spPr/>
         <p:txBody>
           <a:bodyPr/>
           <a:lstStyle/>
@@ -26160,8 +26353,8 @@
         </p:nvSpPr>
         <p:spPr>
           <a:xfrm>
-            <a:off x="815740" y="1305341"/>
-            <a:ext cx="6097604" cy="923330"/>
+            <a:off x="815739" y="1305341"/>
+            <a:ext cx="7621137" cy="923330"/>
           </a:xfrm>
           <a:prstGeom prst="rect">
             <a:avLst/>
@@ -26175,19 +26368,31 @@
           <a:lstStyle/>
           <a:p>
             <a:r>
-              <a:rPr lang="en-US" dirty="0" err="1"/>
+              <a:rPr lang="en-US" dirty="0" err="1">
+                <a:latin typeface="Courier New" panose="02070309020205020404" pitchFamily="49" charset="0"/>
+                <a:cs typeface="Courier New" panose="02070309020205020404" pitchFamily="49" charset="0"/>
+              </a:rPr>
               <a:t>my_tuple</a:t>
             </a:r>
             <a:r>
-              <a:rPr lang="en-US" dirty="0"/>
+              <a:rPr lang="en-US" dirty="0">
+                <a:latin typeface="Courier New" panose="02070309020205020404" pitchFamily="49" charset="0"/>
+                <a:cs typeface="Courier New" panose="02070309020205020404" pitchFamily="49" charset="0"/>
+              </a:rPr>
               <a:t> = (1, 2, 3)</a:t>
             </a:r>
           </a:p>
           <a:p>
-            <a:endParaRPr lang="en-US" dirty="0"/>
-          </a:p>
-          <a:p>
-            <a:endParaRPr lang="en-US" dirty="0"/>
+            <a:endParaRPr lang="en-US" dirty="0">
+              <a:latin typeface="Courier New" panose="02070309020205020404" pitchFamily="49" charset="0"/>
+              <a:cs typeface="Courier New" panose="02070309020205020404" pitchFamily="49" charset="0"/>
+            </a:endParaRPr>
+          </a:p>
+          <a:p>
+            <a:endParaRPr lang="en-US" dirty="0">
+              <a:latin typeface="Courier New" panose="02070309020205020404" pitchFamily="49" charset="0"/>
+              <a:cs typeface="Courier New" panose="02070309020205020404" pitchFamily="49" charset="0"/>
+            </a:endParaRPr>
           </a:p>
         </p:txBody>
       </p:sp>
@@ -26206,7 +26411,7 @@
         <p:spPr>
           <a:xfrm>
             <a:off x="815740" y="1953246"/>
-            <a:ext cx="8068378" cy="1200329"/>
+            <a:ext cx="10084324" cy="1200329"/>
           </a:xfrm>
           <a:prstGeom prst="rect">
             <a:avLst/>
@@ -26220,29 +26425,47 @@
           <a:lstStyle/>
           <a:p>
             <a:r>
-              <a:rPr lang="en-US" dirty="0"/>
+              <a:rPr lang="en-US" dirty="0">
+                <a:latin typeface="Courier New" panose="02070309020205020404" pitchFamily="49" charset="0"/>
+                <a:cs typeface="Courier New" panose="02070309020205020404" pitchFamily="49" charset="0"/>
+              </a:rPr>
               <a:t># Since tuples are immutable, you rarely need to copy them</a:t>
             </a:r>
           </a:p>
           <a:p>
             <a:r>
-              <a:rPr lang="en-US" dirty="0"/>
+              <a:rPr lang="en-US" dirty="0">
+                <a:latin typeface="Courier New" panose="02070309020205020404" pitchFamily="49" charset="0"/>
+                <a:cs typeface="Courier New" panose="02070309020205020404" pitchFamily="49" charset="0"/>
+              </a:rPr>
               <a:t># Simply assign — both variables safely point to the same object</a:t>
             </a:r>
           </a:p>
           <a:p>
             <a:r>
-              <a:rPr lang="en-US" dirty="0"/>
+              <a:rPr lang="en-US" dirty="0">
+                <a:latin typeface="Courier New" panose="02070309020205020404" pitchFamily="49" charset="0"/>
+                <a:cs typeface="Courier New" panose="02070309020205020404" pitchFamily="49" charset="0"/>
+              </a:rPr>
               <a:t>copy = </a:t>
             </a:r>
             <a:r>
-              <a:rPr lang="en-US" dirty="0" err="1"/>
+              <a:rPr lang="en-US" dirty="0" err="1">
+                <a:latin typeface="Courier New" panose="02070309020205020404" pitchFamily="49" charset="0"/>
+                <a:cs typeface="Courier New" panose="02070309020205020404" pitchFamily="49" charset="0"/>
+              </a:rPr>
               <a:t>my_tuple</a:t>
             </a:r>
-            <a:endParaRPr lang="en-US" dirty="0"/>
-          </a:p>
-          <a:p>
-            <a:endParaRPr lang="en-US" dirty="0"/>
+            <a:endParaRPr lang="en-US" dirty="0">
+              <a:latin typeface="Courier New" panose="02070309020205020404" pitchFamily="49" charset="0"/>
+              <a:cs typeface="Courier New" panose="02070309020205020404" pitchFamily="49" charset="0"/>
+            </a:endParaRPr>
+          </a:p>
+          <a:p>
+            <a:endParaRPr lang="en-US" dirty="0">
+              <a:latin typeface="Courier New" panose="02070309020205020404" pitchFamily="49" charset="0"/>
+              <a:cs typeface="Courier New" panose="02070309020205020404" pitchFamily="49" charset="0"/>
+            </a:endParaRPr>
           </a:p>
         </p:txBody>
       </p:sp>
@@ -26261,7 +26484,7 @@
         <p:spPr>
           <a:xfrm>
             <a:off x="815739" y="3704426"/>
-            <a:ext cx="6460959" cy="923330"/>
+            <a:ext cx="8075279" cy="923330"/>
           </a:xfrm>
           <a:prstGeom prst="rect">
             <a:avLst/>
@@ -26275,26 +26498,41 @@
           <a:lstStyle/>
           <a:p>
             <a:r>
-              <a:rPr lang="en-US" dirty="0"/>
+              <a:rPr lang="en-US" dirty="0">
+                <a:latin typeface="Courier New" panose="02070309020205020404" pitchFamily="49" charset="0"/>
+                <a:cs typeface="Courier New" panose="02070309020205020404" pitchFamily="49" charset="0"/>
+              </a:rPr>
               <a:t># tuple() constructor (creates a new object)</a:t>
             </a:r>
           </a:p>
           <a:p>
             <a:r>
-              <a:rPr lang="en-US" dirty="0"/>
+              <a:rPr lang="en-US" dirty="0">
+                <a:latin typeface="Courier New" panose="02070309020205020404" pitchFamily="49" charset="0"/>
+                <a:cs typeface="Courier New" panose="02070309020205020404" pitchFamily="49" charset="0"/>
+              </a:rPr>
               <a:t>copy = tuple(</a:t>
             </a:r>
             <a:r>
-              <a:rPr lang="en-US" dirty="0" err="1"/>
+              <a:rPr lang="en-US" dirty="0" err="1">
+                <a:latin typeface="Courier New" panose="02070309020205020404" pitchFamily="49" charset="0"/>
+                <a:cs typeface="Courier New" panose="02070309020205020404" pitchFamily="49" charset="0"/>
+              </a:rPr>
               <a:t>my_tuple</a:t>
             </a:r>
             <a:r>
-              <a:rPr lang="en-US" dirty="0"/>
+              <a:rPr lang="en-US" dirty="0">
+                <a:latin typeface="Courier New" panose="02070309020205020404" pitchFamily="49" charset="0"/>
+                <a:cs typeface="Courier New" panose="02070309020205020404" pitchFamily="49" charset="0"/>
+              </a:rPr>
               <a:t>)</a:t>
             </a:r>
           </a:p>
           <a:p>
-            <a:endParaRPr lang="en-US" dirty="0"/>
+            <a:endParaRPr lang="en-US" dirty="0">
+              <a:latin typeface="Courier New" panose="02070309020205020404" pitchFamily="49" charset="0"/>
+              <a:cs typeface="Courier New" panose="02070309020205020404" pitchFamily="49" charset="0"/>
+            </a:endParaRPr>
           </a:p>
         </p:txBody>
       </p:sp>
@@ -26313,7 +26551,7 @@
         <p:spPr>
           <a:xfrm>
             <a:off x="815739" y="4722607"/>
-            <a:ext cx="9146407" cy="923330"/>
+            <a:ext cx="11431707" cy="923330"/>
           </a:xfrm>
           <a:prstGeom prst="rect">
             <a:avLst/>
@@ -26327,35 +26565,56 @@
           <a:lstStyle/>
           <a:p>
             <a:r>
-              <a:rPr lang="en-US" dirty="0"/>
+              <a:rPr lang="en-US" dirty="0">
+                <a:latin typeface="Courier New" panose="02070309020205020404" pitchFamily="49" charset="0"/>
+                <a:cs typeface="Courier New" panose="02070309020205020404" pitchFamily="49" charset="0"/>
+              </a:rPr>
               <a:t># Deep copy (use when tuple contains nested mutable objects)</a:t>
             </a:r>
           </a:p>
           <a:p>
             <a:r>
-              <a:rPr lang="en-US" dirty="0"/>
+              <a:rPr lang="en-US" dirty="0">
+                <a:latin typeface="Courier New" panose="02070309020205020404" pitchFamily="49" charset="0"/>
+                <a:cs typeface="Courier New" panose="02070309020205020404" pitchFamily="49" charset="0"/>
+              </a:rPr>
               <a:t>import copy</a:t>
             </a:r>
           </a:p>
           <a:p>
             <a:r>
-              <a:rPr lang="en-US" dirty="0"/>
+              <a:rPr lang="en-US" dirty="0">
+                <a:latin typeface="Courier New" panose="02070309020205020404" pitchFamily="49" charset="0"/>
+                <a:cs typeface="Courier New" panose="02070309020205020404" pitchFamily="49" charset="0"/>
+              </a:rPr>
               <a:t>copy = </a:t>
             </a:r>
             <a:r>
-              <a:rPr lang="en-US" dirty="0" err="1"/>
+              <a:rPr lang="en-US" dirty="0" err="1">
+                <a:latin typeface="Courier New" panose="02070309020205020404" pitchFamily="49" charset="0"/>
+                <a:cs typeface="Courier New" panose="02070309020205020404" pitchFamily="49" charset="0"/>
+              </a:rPr>
               <a:t>copy.deepcopy</a:t>
             </a:r>
             <a:r>
-              <a:rPr lang="en-US" dirty="0"/>
+              <a:rPr lang="en-US" dirty="0">
+                <a:latin typeface="Courier New" panose="02070309020205020404" pitchFamily="49" charset="0"/>
+                <a:cs typeface="Courier New" panose="02070309020205020404" pitchFamily="49" charset="0"/>
+              </a:rPr>
               <a:t>(</a:t>
             </a:r>
             <a:r>
-              <a:rPr lang="en-US" dirty="0" err="1"/>
+              <a:rPr lang="en-US" dirty="0" err="1">
+                <a:latin typeface="Courier New" panose="02070309020205020404" pitchFamily="49" charset="0"/>
+                <a:cs typeface="Courier New" panose="02070309020205020404" pitchFamily="49" charset="0"/>
+              </a:rPr>
               <a:t>my_tuple</a:t>
             </a:r>
             <a:r>
-              <a:rPr lang="en-US" dirty="0"/>
+              <a:rPr lang="en-US" dirty="0">
+                <a:latin typeface="Courier New" panose="02070309020205020404" pitchFamily="49" charset="0"/>
+                <a:cs typeface="Courier New" panose="02070309020205020404" pitchFamily="49" charset="0"/>
+              </a:rPr>
               <a:t>)</a:t>
             </a:r>
           </a:p>
@@ -26558,8 +26817,8 @@
         </p:nvSpPr>
         <p:spPr>
           <a:xfrm>
-            <a:off x="2095900" y="4442134"/>
-            <a:ext cx="7384983" cy="1938992"/>
+            <a:off x="847023" y="4026497"/>
+            <a:ext cx="9958231" cy="2308324"/>
           </a:xfrm>
           <a:prstGeom prst="rect">
             <a:avLst/>
@@ -26572,39 +26831,76 @@
           </a:bodyPr>
           <a:lstStyle/>
           <a:p>
-            <a:endParaRPr lang="en-US" sz="2400" dirty="0"/>
-          </a:p>
-          <a:p>
-            <a:r>
-              <a:rPr lang="en-US" sz="2400" dirty="0"/>
+            <a:endParaRPr lang="en-US" sz="2400" dirty="0">
+              <a:latin typeface="Courier New" panose="02070309020205020404" pitchFamily="49" charset="0"/>
+              <a:cs typeface="Courier New" panose="02070309020205020404" pitchFamily="49" charset="0"/>
+            </a:endParaRPr>
+          </a:p>
+          <a:p>
+            <a:r>
+              <a:rPr lang="en-US" sz="2400" dirty="0">
+                <a:latin typeface="Courier New" panose="02070309020205020404" pitchFamily="49" charset="0"/>
+                <a:cs typeface="Courier New" panose="02070309020205020404" pitchFamily="49" charset="0"/>
+              </a:rPr>
               <a:t># Tuple (immutable) — you CANNOT change it</a:t>
             </a:r>
           </a:p>
           <a:p>
             <a:r>
-              <a:rPr lang="en-US" sz="2400" dirty="0" err="1"/>
+              <a:rPr lang="en-US" sz="2400" dirty="0" err="1">
+                <a:latin typeface="Courier New" panose="02070309020205020404" pitchFamily="49" charset="0"/>
+                <a:cs typeface="Courier New" panose="02070309020205020404" pitchFamily="49" charset="0"/>
+              </a:rPr>
               <a:t>my_tuple</a:t>
             </a:r>
             <a:r>
-              <a:rPr lang="en-US" sz="2400" dirty="0"/>
+              <a:rPr lang="en-US" sz="2400" dirty="0">
+                <a:latin typeface="Courier New" panose="02070309020205020404" pitchFamily="49" charset="0"/>
+                <a:cs typeface="Courier New" panose="02070309020205020404" pitchFamily="49" charset="0"/>
+              </a:rPr>
               <a:t> = (1, 2, 3)</a:t>
             </a:r>
           </a:p>
           <a:p>
             <a:r>
-              <a:rPr lang="en-US" sz="2400" dirty="0" err="1"/>
+              <a:rPr lang="en-US" sz="2400" dirty="0" err="1">
+                <a:latin typeface="Courier New" panose="02070309020205020404" pitchFamily="49" charset="0"/>
+                <a:cs typeface="Courier New" panose="02070309020205020404" pitchFamily="49" charset="0"/>
+              </a:rPr>
               <a:t>my_tuple</a:t>
             </a:r>
             <a:r>
-              <a:rPr lang="en-US" sz="2400" dirty="0"/>
-              <a:t>[0] = 99  # ❌ </a:t>
-            </a:r>
-            <a:r>
-              <a:rPr lang="en-US" sz="2400" dirty="0" err="1"/>
+              <a:rPr lang="en-US" sz="2400" dirty="0">
+                <a:latin typeface="Courier New" panose="02070309020205020404" pitchFamily="49" charset="0"/>
+                <a:cs typeface="Courier New" panose="02070309020205020404" pitchFamily="49" charset="0"/>
+              </a:rPr>
+              <a:t>[0] = 99  </a:t>
+            </a:r>
+            <a:br>
+              <a:rPr lang="en-US" sz="2400" dirty="0">
+                <a:latin typeface="Courier New" panose="02070309020205020404" pitchFamily="49" charset="0"/>
+                <a:cs typeface="Courier New" panose="02070309020205020404" pitchFamily="49" charset="0"/>
+              </a:rPr>
+            </a:br>
+            <a:r>
+              <a:rPr lang="en-US" sz="2400" dirty="0">
+                <a:latin typeface="Courier New" panose="02070309020205020404" pitchFamily="49" charset="0"/>
+                <a:cs typeface="Courier New" panose="02070309020205020404" pitchFamily="49" charset="0"/>
+              </a:rPr>
+              <a:t># ❌ </a:t>
+            </a:r>
+            <a:r>
+              <a:rPr lang="en-US" sz="2400" dirty="0" err="1">
+                <a:latin typeface="Courier New" panose="02070309020205020404" pitchFamily="49" charset="0"/>
+                <a:cs typeface="Courier New" panose="02070309020205020404" pitchFamily="49" charset="0"/>
+              </a:rPr>
               <a:t>TypeError</a:t>
             </a:r>
             <a:r>
-              <a:rPr lang="en-US" sz="2400" dirty="0"/>
+              <a:rPr lang="en-US" sz="2400" dirty="0">
+                <a:latin typeface="Courier New" panose="02070309020205020404" pitchFamily="49" charset="0"/>
+                <a:cs typeface="Courier New" panose="02070309020205020404" pitchFamily="49" charset="0"/>
+              </a:rPr>
               <a:t>: 'tuple' object does not support item assignment</a:t>
             </a:r>
           </a:p>
@@ -26624,8 +26920,8 @@
         </p:nvSpPr>
         <p:spPr>
           <a:xfrm>
-            <a:off x="2095900" y="2789554"/>
-            <a:ext cx="6097604" cy="1569660"/>
+            <a:off x="847023" y="2373917"/>
+            <a:ext cx="8222273" cy="1569660"/>
           </a:xfrm>
           <a:prstGeom prst="rect">
             <a:avLst/>
@@ -26639,41 +26935,65 @@
           <a:lstStyle/>
           <a:p>
             <a:r>
-              <a:rPr lang="en-US" sz="2400" dirty="0"/>
+              <a:rPr lang="en-US" sz="2400" dirty="0">
+                <a:latin typeface="Courier New" panose="02070309020205020404" pitchFamily="49" charset="0"/>
+                <a:cs typeface="Courier New" panose="02070309020205020404" pitchFamily="49" charset="0"/>
+              </a:rPr>
               <a:t># List (mutable) — you CAN change it</a:t>
             </a:r>
           </a:p>
           <a:p>
             <a:r>
-              <a:rPr lang="en-US" sz="2400" dirty="0" err="1"/>
+              <a:rPr lang="en-US" sz="2400" dirty="0" err="1">
+                <a:latin typeface="Courier New" panose="02070309020205020404" pitchFamily="49" charset="0"/>
+                <a:cs typeface="Courier New" panose="02070309020205020404" pitchFamily="49" charset="0"/>
+              </a:rPr>
               <a:t>my_list</a:t>
             </a:r>
             <a:r>
-              <a:rPr lang="en-US" sz="2400" dirty="0"/>
+              <a:rPr lang="en-US" sz="2400" dirty="0">
+                <a:latin typeface="Courier New" panose="02070309020205020404" pitchFamily="49" charset="0"/>
+                <a:cs typeface="Courier New" panose="02070309020205020404" pitchFamily="49" charset="0"/>
+              </a:rPr>
               <a:t> = [1, 2, 3]</a:t>
             </a:r>
           </a:p>
           <a:p>
             <a:r>
-              <a:rPr lang="en-US" sz="2400" dirty="0" err="1"/>
+              <a:rPr lang="en-US" sz="2400" dirty="0" err="1">
+                <a:latin typeface="Courier New" panose="02070309020205020404" pitchFamily="49" charset="0"/>
+                <a:cs typeface="Courier New" panose="02070309020205020404" pitchFamily="49" charset="0"/>
+              </a:rPr>
               <a:t>my_list</a:t>
             </a:r>
             <a:r>
-              <a:rPr lang="en-US" sz="2400" dirty="0"/>
+              <a:rPr lang="en-US" sz="2400" dirty="0">
+                <a:latin typeface="Courier New" panose="02070309020205020404" pitchFamily="49" charset="0"/>
+                <a:cs typeface="Courier New" panose="02070309020205020404" pitchFamily="49" charset="0"/>
+              </a:rPr>
               <a:t>[0] = 99</a:t>
             </a:r>
           </a:p>
           <a:p>
             <a:r>
-              <a:rPr lang="en-US" sz="2400" dirty="0"/>
+              <a:rPr lang="en-US" sz="2400" dirty="0">
+                <a:latin typeface="Courier New" panose="02070309020205020404" pitchFamily="49" charset="0"/>
+                <a:cs typeface="Courier New" panose="02070309020205020404" pitchFamily="49" charset="0"/>
+              </a:rPr>
               <a:t>print(</a:t>
             </a:r>
             <a:r>
-              <a:rPr lang="en-US" sz="2400" dirty="0" err="1"/>
+              <a:rPr lang="en-US" sz="2400" dirty="0" err="1">
+                <a:latin typeface="Courier New" panose="02070309020205020404" pitchFamily="49" charset="0"/>
+                <a:cs typeface="Courier New" panose="02070309020205020404" pitchFamily="49" charset="0"/>
+              </a:rPr>
               <a:t>my_list</a:t>
             </a:r>
             <a:r>
-              <a:rPr lang="en-US" sz="2400" dirty="0"/>
+              <a:rPr lang="en-US" sz="2400" dirty="0">
+                <a:latin typeface="Courier New" panose="02070309020205020404" pitchFamily="49" charset="0"/>
+                <a:cs typeface="Courier New" panose="02070309020205020404" pitchFamily="49" charset="0"/>
+              </a:rPr>
               <a:t>)  # [99, 2, 3]  ✅</a:t>
             </a:r>
           </a:p>
@@ -27033,40 +27353,27 @@
             <a:spLocks noGrp="1"/>
           </p:cNvSpPr>
           <p:nvPr>
-            <p:ph type="body" sz="quarter" idx="11"/>
+            <p:ph idx="1"/>
           </p:nvPr>
         </p:nvSpPr>
-        <p:spPr>
-          <a:xfrm>
-            <a:off x="548640" y="2148840"/>
-            <a:ext cx="11008360" cy="4023360"/>
-          </a:xfrm>
-        </p:spPr>
+        <p:spPr/>
         <p:txBody>
           <a:bodyPr/>
           <a:lstStyle/>
           <a:p>
-            <a:pPr marL="457200" indent="-457200">
-              <a:buFont typeface="Arial" panose="020B0604020202020204" pitchFamily="34" charset="0"/>
-              <a:buChar char="•"/>
-            </a:pPr>
-            <a:r>
-              <a:rPr lang="en-US" dirty="0"/>
+            <a:r>
+              <a:rPr lang="en-US" sz="2400" dirty="0"/>
               <a:t>Mutable and immutable structures</a:t>
             </a:r>
           </a:p>
           <a:p>
-            <a:pPr marL="457200" indent="-457200">
-              <a:buFont typeface="Arial" panose="020B0604020202020204" pitchFamily="34" charset="0"/>
-              <a:buChar char="•"/>
-            </a:pPr>
-            <a:r>
-              <a:rPr lang="en-US" dirty="0"/>
+            <a:r>
+              <a:rPr lang="en-US" sz="2400" dirty="0"/>
               <a:t>Working with tuples and lists</a:t>
             </a:r>
           </a:p>
           <a:p>
-            <a:endParaRPr lang="en-US" dirty="0"/>
+            <a:endParaRPr lang="en-US" sz="2400" dirty="0"/>
           </a:p>
         </p:txBody>
       </p:sp>
@@ -29659,7 +29966,12 @@
             <p:ph type="title"/>
           </p:nvPr>
         </p:nvSpPr>
-        <p:spPr/>
+        <p:spPr>
+          <a:xfrm>
+            <a:off x="548640" y="411481"/>
+            <a:ext cx="8231293" cy="914400"/>
+          </a:xfrm>
+        </p:spPr>
         <p:txBody>
           <a:bodyPr/>
           <a:lstStyle/>
@@ -29698,12 +30010,9 @@
         </p:blipFill>
         <p:spPr>
           <a:xfrm>
-            <a:off x="508000" y="1318800"/>
-            <a:ext cx="11176000" cy="4955141"/>
+            <a:off x="549274" y="1496722"/>
+            <a:ext cx="11265189" cy="4994686"/>
           </a:xfrm>
-          <a:prstGeom prst="rect">
-            <a:avLst/>
-          </a:prstGeom>
           <a:noFill/>
           <a:ln>
             <a:noFill/>
@@ -29724,7 +30033,7 @@
         </p:nvSpPr>
         <p:spPr>
           <a:xfrm>
-            <a:off x="235884" y="3429000"/>
+            <a:off x="173539" y="3636819"/>
             <a:ext cx="6284332" cy="302940"/>
           </a:xfrm>
           <a:prstGeom prst="rect">
@@ -29776,7 +30085,7 @@
 </file>
 
 <file path=ppt/slides/slide20.xml><?xml version="1.0" encoding="utf-8"?>
-<p:sld xmlns:a="http://schemas.openxmlformats.org/drawingml/2006/main" xmlns:r="http://schemas.openxmlformats.org/officeDocument/2006/relationships" xmlns:p="http://schemas.openxmlformats.org/presentationml/2006/main">
+<p:sld xmlns:a="http://schemas.openxmlformats.org/drawingml/2006/main" xmlns:r="http://schemas.openxmlformats.org/officeDocument/2006/relationships" xmlns:p="http://schemas.openxmlformats.org/presentationml/2006/main" show="0">
   <p:cSld>
     <p:spTree>
       <p:nvGrpSpPr>
@@ -29798,44 +30107,6 @@
           <a:chExt cx="0" cy="0"/>
         </a:xfrm>
       </p:grpSpPr>
-      <p:sp>
-        <p:nvSpPr>
-          <p:cNvPr id="5" name="Title 4">
-            <a:extLst>
-              <a:ext uri="{FF2B5EF4-FFF2-40B4-BE49-F238E27FC236}">
-                <a16:creationId xmlns:a16="http://schemas.microsoft.com/office/drawing/2014/main" id="{085B9BDB-991C-B226-B138-EDE7827173D2}"/>
-              </a:ext>
-            </a:extLst>
-          </p:cNvPr>
-          <p:cNvSpPr>
-            <a:spLocks noGrp="1"/>
-          </p:cNvSpPr>
-          <p:nvPr>
-            <p:ph type="title"/>
-          </p:nvPr>
-        </p:nvSpPr>
-        <p:spPr>
-          <a:xfrm>
-            <a:off x="549275" y="388461"/>
-            <a:ext cx="9519173" cy="1189037"/>
-          </a:xfrm>
-        </p:spPr>
-        <p:txBody>
-          <a:bodyPr/>
-          <a:lstStyle/>
-          <a:p>
-            <a:r>
-              <a:rPr lang="en-US" dirty="0"/>
-              <a:t>Dictionary methods </a:t>
-            </a:r>
-            <a:r>
-              <a:rPr lang="en-US" dirty="0" err="1"/>
-              <a:t>cheatsheet</a:t>
-            </a:r>
-            <a:endParaRPr lang="en-US" dirty="0"/>
-          </a:p>
-        </p:txBody>
-      </p:sp>
       <p:graphicFrame>
         <p:nvGraphicFramePr>
           <p:cNvPr id="2" name="Table 1">
@@ -29904,7 +30175,7 @@
                         <a:buNone/>
                       </a:pPr>
                       <a:r>
-                        <a:rPr lang="en-US" sz="1400"/>
+                        <a:rPr lang="en-US" sz="1400" dirty="0"/>
                         <a:t>Method</a:t>
                       </a:r>
                     </a:p>
@@ -32975,6 +33246,39 @@
           </a:graphicData>
         </a:graphic>
       </p:graphicFrame>
+      <p:sp>
+        <p:nvSpPr>
+          <p:cNvPr id="5" name="Title 4">
+            <a:extLst>
+              <a:ext uri="{FF2B5EF4-FFF2-40B4-BE49-F238E27FC236}">
+                <a16:creationId xmlns:a16="http://schemas.microsoft.com/office/drawing/2014/main" id="{085B9BDB-991C-B226-B138-EDE7827173D2}"/>
+              </a:ext>
+            </a:extLst>
+          </p:cNvPr>
+          <p:cNvSpPr>
+            <a:spLocks noGrp="1"/>
+          </p:cNvSpPr>
+          <p:nvPr>
+            <p:ph type="title"/>
+          </p:nvPr>
+        </p:nvSpPr>
+        <p:spPr/>
+        <p:txBody>
+          <a:bodyPr/>
+          <a:lstStyle/>
+          <a:p>
+            <a:r>
+              <a:rPr lang="en-US" dirty="0"/>
+              <a:t>Dictionary methods </a:t>
+            </a:r>
+            <a:r>
+              <a:rPr lang="en-US" dirty="0" err="1"/>
+              <a:t>cheatsheet</a:t>
+            </a:r>
+            <a:endParaRPr lang="en-US" dirty="0"/>
+          </a:p>
+        </p:txBody>
+      </p:sp>
     </p:spTree>
     <p:extLst>
       <p:ext uri="{BB962C8B-B14F-4D97-AF65-F5344CB8AC3E}">
@@ -35933,7 +36237,7 @@
 </file>
 
 <file path=ppt/slides/slide23.xml><?xml version="1.0" encoding="utf-8"?>
-<p:sld xmlns:a="http://schemas.openxmlformats.org/drawingml/2006/main" xmlns:r="http://schemas.openxmlformats.org/officeDocument/2006/relationships" xmlns:p="http://schemas.openxmlformats.org/presentationml/2006/main">
+<p:sld xmlns:a="http://schemas.openxmlformats.org/drawingml/2006/main" xmlns:r="http://schemas.openxmlformats.org/officeDocument/2006/relationships" xmlns:p="http://schemas.openxmlformats.org/presentationml/2006/main" show="0">
   <p:cSld>
     <p:spTree>
       <p:nvGrpSpPr>
@@ -38610,6 +38914,170 @@
       </p:grpSpPr>
       <p:sp>
         <p:nvSpPr>
+          <p:cNvPr id="3" name="TextBox 2">
+            <a:extLst>
+              <a:ext uri="{FF2B5EF4-FFF2-40B4-BE49-F238E27FC236}">
+                <a16:creationId xmlns:a16="http://schemas.microsoft.com/office/drawing/2014/main" id="{B23A87AD-36CB-80ED-9F59-422092F8BFC4}"/>
+              </a:ext>
+            </a:extLst>
+          </p:cNvPr>
+          <p:cNvSpPr txBox="1"/>
+          <p:nvPr/>
+        </p:nvSpPr>
+        <p:spPr>
+          <a:xfrm>
+            <a:off x="374303" y="875371"/>
+            <a:ext cx="11481724" cy="5509200"/>
+          </a:xfrm>
+          <a:prstGeom prst="rect">
+            <a:avLst/>
+          </a:prstGeom>
+          <a:noFill/>
+        </p:spPr>
+        <p:txBody>
+          <a:bodyPr wrap="square">
+            <a:spAutoFit/>
+          </a:bodyPr>
+          <a:lstStyle/>
+          <a:p>
+            <a:r>
+              <a:rPr lang="en-US" sz="2200" dirty="0"/>
+              <a:t>A military base has two lists of personnel — soldiers who are </a:t>
+            </a:r>
+            <a:r>
+              <a:rPr lang="en-US" sz="2200" b="1" dirty="0"/>
+              <a:t>authorized</a:t>
+            </a:r>
+            <a:r>
+              <a:rPr lang="en-US" sz="2200" dirty="0"/>
+              <a:t> to enter a restricted zone, and soldiers who </a:t>
+            </a:r>
+            <a:r>
+              <a:rPr lang="en-US" sz="2200" b="1" dirty="0"/>
+              <a:t>showed up</a:t>
+            </a:r>
+            <a:r>
+              <a:rPr lang="en-US" sz="2200" dirty="0"/>
+              <a:t> at the gate today. Your job is to write a function that uses sets to help the security officer quickly answer three questions:</a:t>
+            </a:r>
+          </a:p>
+          <a:p>
+            <a:endParaRPr lang="en-US" sz="2200" dirty="0"/>
+          </a:p>
+          <a:p>
+            <a:r>
+              <a:rPr lang="en-US" sz="2200" dirty="0"/>
+              <a:t>Who showed up that is </a:t>
+            </a:r>
+            <a:r>
+              <a:rPr lang="en-US" sz="2200" b="1" dirty="0"/>
+              <a:t>authorized</a:t>
+            </a:r>
+            <a:r>
+              <a:rPr lang="en-US" sz="2200" dirty="0"/>
+              <a:t>? (let them in)</a:t>
+            </a:r>
+          </a:p>
+          <a:p>
+            <a:r>
+              <a:rPr lang="en-US" sz="2200" dirty="0"/>
+              <a:t>Who showed up that is </a:t>
+            </a:r>
+            <a:r>
+              <a:rPr lang="en-US" sz="2200" b="1" dirty="0"/>
+              <a:t>not authorized</a:t>
+            </a:r>
+            <a:r>
+              <a:rPr lang="en-US" sz="2200" dirty="0"/>
+              <a:t>? (turn them away)</a:t>
+            </a:r>
+          </a:p>
+          <a:p>
+            <a:r>
+              <a:rPr lang="en-US" sz="2200" dirty="0"/>
+              <a:t>Who is authorized but </a:t>
+            </a:r>
+            <a:r>
+              <a:rPr lang="en-US" sz="2200" b="1" dirty="0"/>
+              <a:t>didn't show up</a:t>
+            </a:r>
+            <a:r>
+              <a:rPr lang="en-US" sz="2200" dirty="0"/>
+              <a:t>? (report as absent)</a:t>
+            </a:r>
+          </a:p>
+          <a:p>
+            <a:endParaRPr lang="en-US" sz="2200" dirty="0"/>
+          </a:p>
+          <a:p>
+            <a:pPr marL="457200" indent="-457200">
+              <a:buAutoNum type="arabicParenR"/>
+            </a:pPr>
+            <a:r>
+              <a:rPr lang="en-US" sz="2200" dirty="0"/>
+              <a:t>Store the two groups as sets </a:t>
+            </a:r>
+          </a:p>
+          <a:p>
+            <a:pPr marL="457200" indent="-457200">
+              <a:buAutoNum type="arabicParenR"/>
+            </a:pPr>
+            <a:r>
+              <a:rPr lang="en-US" sz="2200" dirty="0"/>
+              <a:t>Write a function </a:t>
+            </a:r>
+            <a:r>
+              <a:rPr lang="en-US" sz="2200" dirty="0" err="1"/>
+              <a:t>check_gate</a:t>
+            </a:r>
+            <a:r>
+              <a:rPr lang="en-US" sz="2200" dirty="0"/>
+              <a:t>(authorized, arrived) that returns all three answers using set operations </a:t>
+            </a:r>
+          </a:p>
+          <a:p>
+            <a:pPr marL="457200" indent="-457200">
+              <a:buAutoNum type="arabicParenR"/>
+            </a:pPr>
+            <a:r>
+              <a:rPr lang="en-US" sz="2200" dirty="0"/>
+              <a:t>Print each result clearly</a:t>
+            </a:r>
+          </a:p>
+          <a:p>
+            <a:pPr marL="457200" indent="-457200">
+              <a:buAutoNum type="arabicParenR"/>
+            </a:pPr>
+            <a:endParaRPr lang="en-US" sz="2200" dirty="0"/>
+          </a:p>
+          <a:p>
+            <a:r>
+              <a:rPr lang="en-US" sz="2200" dirty="0"/>
+              <a:t>Starter Code:</a:t>
+            </a:r>
+          </a:p>
+          <a:p>
+            <a:r>
+              <a:rPr lang="en-US" sz="2200" dirty="0">
+                <a:latin typeface="Courier New" panose="02070309020205020404" pitchFamily="49" charset="0"/>
+                <a:cs typeface="Courier New" panose="02070309020205020404" pitchFamily="49" charset="0"/>
+              </a:rPr>
+              <a:t>authorized = {"Smith", "Johnson", "Williams", "Brown", "Davis"} </a:t>
+            </a:r>
+          </a:p>
+          <a:p>
+            <a:r>
+              <a:rPr lang="en-US" sz="2200" dirty="0">
+                <a:latin typeface="Courier New" panose="02070309020205020404" pitchFamily="49" charset="0"/>
+                <a:cs typeface="Courier New" panose="02070309020205020404" pitchFamily="49" charset="0"/>
+              </a:rPr>
+              <a:t>arrived = {"Smith", "Davis", "Williams", "Rodriguez"}</a:t>
+            </a:r>
+          </a:p>
+        </p:txBody>
+      </p:sp>
+      <p:sp>
+        <p:nvSpPr>
           <p:cNvPr id="5" name="Title 4">
             <a:extLst>
               <a:ext uri="{FF2B5EF4-FFF2-40B4-BE49-F238E27FC236}">
@@ -38632,210 +39100,6 @@
             <a:r>
               <a:rPr lang="en-US" dirty="0"/>
               <a:t>Hands-On #3 - sets</a:t>
-            </a:r>
-          </a:p>
-        </p:txBody>
-      </p:sp>
-      <p:sp>
-        <p:nvSpPr>
-          <p:cNvPr id="3" name="TextBox 2">
-            <a:extLst>
-              <a:ext uri="{FF2B5EF4-FFF2-40B4-BE49-F238E27FC236}">
-                <a16:creationId xmlns:a16="http://schemas.microsoft.com/office/drawing/2014/main" id="{B23A87AD-36CB-80ED-9F59-422092F8BFC4}"/>
-              </a:ext>
-            </a:extLst>
-          </p:cNvPr>
-          <p:cNvSpPr txBox="1"/>
-          <p:nvPr/>
-        </p:nvSpPr>
-        <p:spPr>
-          <a:xfrm>
-            <a:off x="374303" y="875371"/>
-            <a:ext cx="9985548" cy="5847755"/>
-          </a:xfrm>
-          <a:prstGeom prst="rect">
-            <a:avLst/>
-          </a:prstGeom>
-          <a:noFill/>
-        </p:spPr>
-        <p:txBody>
-          <a:bodyPr wrap="square">
-            <a:spAutoFit/>
-          </a:bodyPr>
-          <a:lstStyle/>
-          <a:p>
-            <a:r>
-              <a:rPr lang="en-US" sz="2200" dirty="0"/>
-              <a:t>A military base has two lists of personnel — soldiers who are </a:t>
-            </a:r>
-            <a:r>
-              <a:rPr lang="en-US" sz="2200" b="1" dirty="0"/>
-              <a:t>authorized</a:t>
-            </a:r>
-            <a:r>
-              <a:rPr lang="en-US" sz="2200" dirty="0"/>
-              <a:t> to enter a restricted zone, and soldiers who </a:t>
-            </a:r>
-            <a:r>
-              <a:rPr lang="en-US" sz="2200" b="1" dirty="0"/>
-              <a:t>showed up</a:t>
-            </a:r>
-            <a:r>
-              <a:rPr lang="en-US" sz="2200" dirty="0"/>
-              <a:t> at the gate today. Your job is to write a function that uses sets to help the security officer quickly answer three questions:</a:t>
-            </a:r>
-          </a:p>
-          <a:p>
-            <a:endParaRPr lang="en-US" sz="2200" dirty="0"/>
-          </a:p>
-          <a:p>
-            <a:r>
-              <a:rPr lang="en-US" sz="2200" dirty="0"/>
-              <a:t>Who showed up that is </a:t>
-            </a:r>
-            <a:r>
-              <a:rPr lang="en-US" sz="2200" b="1" dirty="0"/>
-              <a:t>authorized</a:t>
-            </a:r>
-            <a:r>
-              <a:rPr lang="en-US" sz="2200" dirty="0"/>
-              <a:t>? (let them in)</a:t>
-            </a:r>
-          </a:p>
-          <a:p>
-            <a:r>
-              <a:rPr lang="en-US" sz="2200" dirty="0"/>
-              <a:t>Who showed up that is </a:t>
-            </a:r>
-            <a:r>
-              <a:rPr lang="en-US" sz="2200" b="1" dirty="0"/>
-              <a:t>not authorized</a:t>
-            </a:r>
-            <a:r>
-              <a:rPr lang="en-US" sz="2200" dirty="0"/>
-              <a:t>? (turn them away)</a:t>
-            </a:r>
-          </a:p>
-          <a:p>
-            <a:r>
-              <a:rPr lang="en-US" sz="2200" dirty="0"/>
-              <a:t>Who is authorized but </a:t>
-            </a:r>
-            <a:r>
-              <a:rPr lang="en-US" sz="2200" b="1" dirty="0"/>
-              <a:t>didn't show up</a:t>
-            </a:r>
-            <a:r>
-              <a:rPr lang="en-US" sz="2200" dirty="0"/>
-              <a:t>? (report as absent)</a:t>
-            </a:r>
-          </a:p>
-          <a:p>
-            <a:endParaRPr lang="en-US" sz="2200" dirty="0"/>
-          </a:p>
-          <a:p>
-            <a:pPr marL="457200" indent="-457200">
-              <a:buAutoNum type="arabicParenR"/>
-            </a:pPr>
-            <a:r>
-              <a:rPr lang="en-US" sz="2200" dirty="0"/>
-              <a:t>Store the two groups as sets </a:t>
-            </a:r>
-          </a:p>
-          <a:p>
-            <a:pPr marL="457200" indent="-457200">
-              <a:buAutoNum type="arabicParenR"/>
-            </a:pPr>
-            <a:r>
-              <a:rPr lang="en-US" sz="2200" dirty="0"/>
-              <a:t>Write a function </a:t>
-            </a:r>
-            <a:r>
-              <a:rPr lang="en-US" sz="2200" dirty="0" err="1"/>
-              <a:t>check_gate</a:t>
-            </a:r>
-            <a:r>
-              <a:rPr lang="en-US" sz="2200" dirty="0"/>
-              <a:t>(authorized, arrived) that returns all three answers using set operations </a:t>
-            </a:r>
-          </a:p>
-          <a:p>
-            <a:pPr marL="457200" indent="-457200">
-              <a:buAutoNum type="arabicParenR"/>
-            </a:pPr>
-            <a:r>
-              <a:rPr lang="en-US" sz="2200" dirty="0"/>
-              <a:t>Print each result clearly</a:t>
-            </a:r>
-          </a:p>
-          <a:p>
-            <a:pPr marL="457200" indent="-457200">
-              <a:buAutoNum type="arabicParenR"/>
-            </a:pPr>
-            <a:endParaRPr lang="en-US" sz="2200" dirty="0"/>
-          </a:p>
-          <a:p>
-            <a:r>
-              <a:rPr lang="en-US" sz="2200" dirty="0"/>
-              <a:t>Starter Code:</a:t>
-            </a:r>
-          </a:p>
-          <a:p>
-            <a:r>
-              <a:rPr lang="en-US" sz="2200" dirty="0"/>
-              <a:t>authorized = {"Smith", "Johnson", "Williams", "Brown", "Davis"} </a:t>
-            </a:r>
-          </a:p>
-          <a:p>
-            <a:r>
-              <a:rPr lang="en-US" sz="2200" dirty="0"/>
-              <a:t>arrived = {"Smith", "Davis", "Williams", "Rodriguez"}</a:t>
-            </a:r>
-          </a:p>
-        </p:txBody>
-      </p:sp>
-      <p:sp>
-        <p:nvSpPr>
-          <p:cNvPr id="2" name="TextBox 1">
-            <a:extLst>
-              <a:ext uri="{FF2B5EF4-FFF2-40B4-BE49-F238E27FC236}">
-                <a16:creationId xmlns:a16="http://schemas.microsoft.com/office/drawing/2014/main" id="{151857F8-1250-41C3-7653-2BF7ECD9F293}"/>
-              </a:ext>
-            </a:extLst>
-          </p:cNvPr>
-          <p:cNvSpPr txBox="1"/>
-          <p:nvPr/>
-        </p:nvSpPr>
-        <p:spPr>
-          <a:xfrm>
-            <a:off x="6277893" y="5068229"/>
-            <a:ext cx="914400" cy="914400"/>
-          </a:xfrm>
-          <a:prstGeom prst="rect">
-            <a:avLst/>
-          </a:prstGeom>
-          <a:noFill/>
-        </p:spPr>
-        <p:txBody>
-          <a:bodyPr wrap="none" lIns="0" tIns="0" rIns="0" bIns="0" rtlCol="0">
-            <a:noAutofit/>
-          </a:bodyPr>
-          <a:lstStyle/>
-          <a:p>
-            <a:pPr marL="182880" indent="-182880">
-              <a:lnSpc>
-                <a:spcPct val="95000"/>
-              </a:lnSpc>
-              <a:spcBef>
-                <a:spcPts val="1000"/>
-              </a:spcBef>
-              <a:buSzPct val="100000"/>
-              <a:buFont typeface="Arial"/>
-              <a:buChar char="▪"/>
-            </a:pPr>
-            <a:r>
-              <a:rPr lang="en-US" sz="1700" dirty="0"/>
-              <a:t>HINT: explore .intersection() and .difference() methods</a:t>
             </a:r>
           </a:p>
         </p:txBody>
@@ -38948,21 +39212,33 @@
           </a:p>
           <a:p>
             <a:r>
-              <a:rPr lang="en-US" sz="2200" dirty="0"/>
-              <a:t>“”” </a:t>
-            </a:r>
-          </a:p>
-          <a:p>
-            <a:r>
-              <a:rPr lang="en-US" sz="2200" dirty="0"/>
+              <a:rPr lang="en-US" sz="2200" dirty="0">
+                <a:latin typeface="Courier New" panose="02070309020205020404" pitchFamily="49" charset="0"/>
+                <a:cs typeface="Courier New" panose="02070309020205020404" pitchFamily="49" charset="0"/>
+              </a:rPr>
+              <a:t>""" </a:t>
+            </a:r>
+          </a:p>
+          <a:p>
+            <a:r>
+              <a:rPr lang="en-US" sz="2200" dirty="0">
+                <a:latin typeface="Courier New" panose="02070309020205020404" pitchFamily="49" charset="0"/>
+                <a:cs typeface="Courier New" panose="02070309020205020404" pitchFamily="49" charset="0"/>
+              </a:rPr>
               <a:t>Song lyrics</a:t>
             </a:r>
             <a:br>
-              <a:rPr lang="en-US" sz="2200" dirty="0"/>
+              <a:rPr lang="en-US" sz="2200" dirty="0">
+                <a:latin typeface="Courier New" panose="02070309020205020404" pitchFamily="49" charset="0"/>
+                <a:cs typeface="Courier New" panose="02070309020205020404" pitchFamily="49" charset="0"/>
+              </a:rPr>
             </a:br>
             <a:r>
-              <a:rPr lang="en-US" sz="2200" dirty="0"/>
-              <a:t>“””</a:t>
+              <a:rPr lang="en-US" sz="2200" dirty="0">
+                <a:latin typeface="Courier New" panose="02070309020205020404" pitchFamily="49" charset="0"/>
+                <a:cs typeface="Courier New" panose="02070309020205020404" pitchFamily="49" charset="0"/>
+              </a:rPr>
+              <a:t>"""</a:t>
             </a:r>
           </a:p>
           <a:p>
@@ -38981,41 +39257,6 @@
             <a:r>
               <a:rPr lang="en-US" sz="2200" dirty="0"/>
               <a:t>Using your set, and the initial song lyrics, create a dictionary that contains each word as a key, and the number of times it shows up in your favorite song as the value.</a:t>
-            </a:r>
-          </a:p>
-        </p:txBody>
-      </p:sp>
-      <p:sp>
-        <p:nvSpPr>
-          <p:cNvPr id="6" name="TextBox 5">
-            <a:extLst>
-              <a:ext uri="{FF2B5EF4-FFF2-40B4-BE49-F238E27FC236}">
-                <a16:creationId xmlns:a16="http://schemas.microsoft.com/office/drawing/2014/main" id="{F6E55593-3FD7-6ABE-C6B9-5E7A5E3FDB3B}"/>
-              </a:ext>
-            </a:extLst>
-          </p:cNvPr>
-          <p:cNvSpPr txBox="1"/>
-          <p:nvPr/>
-        </p:nvSpPr>
-        <p:spPr>
-          <a:xfrm>
-            <a:off x="374301" y="5382464"/>
-            <a:ext cx="11352123" cy="646331"/>
-          </a:xfrm>
-          <a:prstGeom prst="rect">
-            <a:avLst/>
-          </a:prstGeom>
-          <a:noFill/>
-        </p:spPr>
-        <p:txBody>
-          <a:bodyPr wrap="square">
-            <a:spAutoFit/>
-          </a:bodyPr>
-          <a:lstStyle/>
-          <a:p>
-            <a:r>
-              <a:rPr lang="en-US" sz="1800" dirty="0"/>
-              <a:t>Hint:  You may need to use the split() method, and other methods to clean up your song lyrics before finding all of the unique words.</a:t>
             </a:r>
           </a:p>
         </p:txBody>
@@ -39080,10 +39321,10 @@
       </p:sp>
       <p:sp>
         <p:nvSpPr>
-          <p:cNvPr id="2" name="Text Placeholder 1">
+          <p:cNvPr id="5" name="Content Placeholder 4">
             <a:extLst>
               <a:ext uri="{FF2B5EF4-FFF2-40B4-BE49-F238E27FC236}">
-                <a16:creationId xmlns:a16="http://schemas.microsoft.com/office/drawing/2014/main" id="{D734D349-7CB9-0570-C5A9-74E3AAE2B479}"/>
+                <a16:creationId xmlns:a16="http://schemas.microsoft.com/office/drawing/2014/main" id="{9B084EE7-C690-8479-F16A-1F2AA0F3C9EB}"/>
               </a:ext>
             </a:extLst>
           </p:cNvPr>
@@ -39091,7 +39332,7 @@
             <a:spLocks noGrp="1"/>
           </p:cNvSpPr>
           <p:nvPr>
-            <p:ph type="body" sz="quarter" idx="11"/>
+            <p:ph idx="1"/>
           </p:nvPr>
         </p:nvSpPr>
         <p:spPr/>
@@ -39156,10 +39397,6 @@
           </p:nvPr>
         </p:nvSpPr>
         <p:spPr>
-          <a:xfrm>
-            <a:off x="4771235" y="2834482"/>
-            <a:ext cx="8231293" cy="1189037"/>
-          </a:xfrm>
           <a:noFill/>
           <a:ln>
             <a:noFill/>
@@ -39176,6 +39413,31 @@
               <a:rPr lang="en-US" dirty="0"/>
               <a:t>Review</a:t>
             </a:r>
+          </a:p>
+        </p:txBody>
+      </p:sp>
+      <p:sp>
+        <p:nvSpPr>
+          <p:cNvPr id="4" name="Content Placeholder 3">
+            <a:extLst>
+              <a:ext uri="{FF2B5EF4-FFF2-40B4-BE49-F238E27FC236}">
+                <a16:creationId xmlns:a16="http://schemas.microsoft.com/office/drawing/2014/main" id="{2FEC59DF-A78A-77BB-FF5A-B87C235E432B}"/>
+              </a:ext>
+            </a:extLst>
+          </p:cNvPr>
+          <p:cNvSpPr>
+            <a:spLocks noGrp="1"/>
+          </p:cNvSpPr>
+          <p:nvPr>
+            <p:ph idx="1"/>
+          </p:nvPr>
+        </p:nvSpPr>
+        <p:spPr/>
+        <p:txBody>
+          <a:bodyPr/>
+          <a:lstStyle/>
+          <a:p>
+            <a:endParaRPr lang="en-US"/>
           </a:p>
         </p:txBody>
       </p:sp>
@@ -39232,10 +39494,6 @@
           </p:nvPr>
         </p:nvSpPr>
         <p:spPr>
-          <a:xfrm>
-            <a:off x="2421602" y="3035881"/>
-            <a:ext cx="8231293" cy="1189037"/>
-          </a:xfrm>
           <a:noFill/>
           <a:ln>
             <a:noFill/>
@@ -39243,7 +39501,7 @@
         </p:spPr>
         <p:txBody>
           <a:bodyPr spcFirstLastPara="1" vert="horz" wrap="square" lIns="121900" tIns="121900" rIns="121900" bIns="121900" rtlCol="0" anchor="t" anchorCtr="0">
-            <a:normAutofit fontScale="90000"/>
+            <a:normAutofit/>
           </a:bodyPr>
           <a:lstStyle/>
           <a:p>
@@ -39252,6 +39510,31 @@
               <a:rPr lang="en-US" dirty="0"/>
               <a:t>What did we do last lesson?</a:t>
             </a:r>
+          </a:p>
+        </p:txBody>
+      </p:sp>
+      <p:sp>
+        <p:nvSpPr>
+          <p:cNvPr id="4" name="Content Placeholder 3">
+            <a:extLst>
+              <a:ext uri="{FF2B5EF4-FFF2-40B4-BE49-F238E27FC236}">
+                <a16:creationId xmlns:a16="http://schemas.microsoft.com/office/drawing/2014/main" id="{60486BA6-0431-62DD-DB8B-6DBD98AE99D8}"/>
+              </a:ext>
+            </a:extLst>
+          </p:cNvPr>
+          <p:cNvSpPr>
+            <a:spLocks noGrp="1"/>
+          </p:cNvSpPr>
+          <p:nvPr>
+            <p:ph idx="1"/>
+          </p:nvPr>
+        </p:nvSpPr>
+        <p:spPr/>
+        <p:txBody>
+          <a:bodyPr/>
+          <a:lstStyle/>
+          <a:p>
+            <a:endParaRPr lang="en-US"/>
           </a:p>
         </p:txBody>
       </p:sp>
@@ -39308,10 +39591,6 @@
           </p:nvPr>
         </p:nvSpPr>
         <p:spPr>
-          <a:xfrm>
-            <a:off x="640928" y="629565"/>
-            <a:ext cx="8231293" cy="1189037"/>
-          </a:xfrm>
           <a:noFill/>
           <a:ln>
             <a:noFill/>
@@ -39333,297 +39612,44 @@
       </p:sp>
       <p:sp>
         <p:nvSpPr>
-          <p:cNvPr id="2" name="Content Placeholder 2">
+          <p:cNvPr id="5" name="Content Placeholder 4">
             <a:extLst>
               <a:ext uri="{FF2B5EF4-FFF2-40B4-BE49-F238E27FC236}">
-                <a16:creationId xmlns:a16="http://schemas.microsoft.com/office/drawing/2014/main" id="{26BFF574-D87F-5665-E149-A6F07BF5762A}"/>
+                <a16:creationId xmlns:a16="http://schemas.microsoft.com/office/drawing/2014/main" id="{818212B1-6C1D-CE78-BC41-A6F429DFC83F}"/>
               </a:ext>
             </a:extLst>
           </p:cNvPr>
-          <p:cNvSpPr txBox="1">
-            <a:spLocks/>
+          <p:cNvSpPr>
+            <a:spLocks noGrp="1"/>
           </p:cNvSpPr>
-          <p:nvPr/>
+          <p:nvPr>
+            <p:ph idx="1"/>
+          </p:nvPr>
         </p:nvSpPr>
         <p:spPr>
           <a:xfrm>
-            <a:off x="558265" y="1542449"/>
-            <a:ext cx="10601960" cy="4023360"/>
+            <a:off x="548640" y="1600198"/>
+            <a:ext cx="9624060" cy="4572000"/>
           </a:xfrm>
-          <a:prstGeom prst="rect">
-            <a:avLst/>
-          </a:prstGeom>
         </p:spPr>
         <p:txBody>
           <a:bodyPr/>
-          <a:lstStyle>
-            <a:lvl1pPr marL="182880" indent="-182880" algn="l" defTabSz="914400" rtl="0" eaLnBrk="1" latinLnBrk="0" hangingPunct="1">
-              <a:lnSpc>
-                <a:spcPct val="95000"/>
-              </a:lnSpc>
-              <a:spcBef>
-                <a:spcPts val="1000"/>
-              </a:spcBef>
-              <a:buFont typeface="Arial" panose="020B0604020202020204" pitchFamily="34" charset="0"/>
-              <a:buChar char="▪"/>
-              <a:defRPr sz="1700" kern="1200">
-                <a:solidFill>
-                  <a:schemeClr val="tx1"/>
-                </a:solidFill>
-                <a:latin typeface="+mn-lt"/>
-                <a:ea typeface="+mn-ea"/>
-                <a:cs typeface="+mn-cs"/>
-              </a:defRPr>
-            </a:lvl1pPr>
-            <a:lvl2pPr marL="365760" indent="-182880" algn="l" defTabSz="914400" rtl="0" eaLnBrk="1" latinLnBrk="0" hangingPunct="1">
-              <a:lnSpc>
-                <a:spcPct val="95000"/>
-              </a:lnSpc>
-              <a:spcBef>
-                <a:spcPts val="500"/>
-              </a:spcBef>
-              <a:buFont typeface="Arial" panose="020B0604020202020204" pitchFamily="34" charset="0"/>
-              <a:buChar char="–"/>
-              <a:defRPr sz="1700" kern="1200">
-                <a:solidFill>
-                  <a:schemeClr val="tx1"/>
-                </a:solidFill>
-                <a:latin typeface="+mn-lt"/>
-                <a:ea typeface="+mn-ea"/>
-                <a:cs typeface="+mn-cs"/>
-              </a:defRPr>
-            </a:lvl2pPr>
-            <a:lvl3pPr marL="548640" indent="-182880" algn="l" defTabSz="914400" rtl="0" eaLnBrk="1" latinLnBrk="0" hangingPunct="1">
-              <a:lnSpc>
-                <a:spcPct val="95000"/>
-              </a:lnSpc>
-              <a:spcBef>
-                <a:spcPts val="500"/>
-              </a:spcBef>
-              <a:buFont typeface="Arial" panose="020B0604020202020204" pitchFamily="34" charset="0"/>
-              <a:buChar char="–"/>
-              <a:defRPr sz="1700" kern="1200">
-                <a:solidFill>
-                  <a:schemeClr val="tx1"/>
-                </a:solidFill>
-                <a:latin typeface="+mn-lt"/>
-                <a:ea typeface="+mn-ea"/>
-                <a:cs typeface="+mn-cs"/>
-              </a:defRPr>
-            </a:lvl3pPr>
-            <a:lvl4pPr marL="731520" indent="-182880" algn="l" defTabSz="914400" rtl="0" eaLnBrk="1" latinLnBrk="0" hangingPunct="1">
-              <a:lnSpc>
-                <a:spcPct val="95000"/>
-              </a:lnSpc>
-              <a:spcBef>
-                <a:spcPts val="500"/>
-              </a:spcBef>
-              <a:buFont typeface="Arial" panose="020B0604020202020204" pitchFamily="34" charset="0"/>
-              <a:buChar char="–"/>
-              <a:defRPr sz="1700" kern="1200">
-                <a:solidFill>
-                  <a:schemeClr val="tx1"/>
-                </a:solidFill>
-                <a:latin typeface="+mn-lt"/>
-                <a:ea typeface="+mn-ea"/>
-                <a:cs typeface="+mn-cs"/>
-              </a:defRPr>
-            </a:lvl4pPr>
-            <a:lvl5pPr marL="914400" indent="-182880" algn="l" defTabSz="914400" rtl="0" eaLnBrk="1" latinLnBrk="0" hangingPunct="1">
-              <a:lnSpc>
-                <a:spcPct val="95000"/>
-              </a:lnSpc>
-              <a:spcBef>
-                <a:spcPts val="500"/>
-              </a:spcBef>
-              <a:buFont typeface="Arial" panose="020B0604020202020204" pitchFamily="34" charset="0"/>
-              <a:buChar char="–"/>
-              <a:defRPr sz="1700" kern="1200">
-                <a:solidFill>
-                  <a:schemeClr val="tx1"/>
-                </a:solidFill>
-                <a:latin typeface="+mn-lt"/>
-                <a:ea typeface="+mn-ea"/>
-                <a:cs typeface="+mn-cs"/>
-              </a:defRPr>
-            </a:lvl5pPr>
-            <a:lvl6pPr marL="1097280" indent="-182880" algn="l" defTabSz="914400" rtl="0" eaLnBrk="1" latinLnBrk="0" hangingPunct="1">
-              <a:lnSpc>
-                <a:spcPct val="95000"/>
-              </a:lnSpc>
-              <a:spcBef>
-                <a:spcPts val="500"/>
-              </a:spcBef>
-              <a:buFont typeface="Arial" panose="020B0604020202020204" pitchFamily="34" charset="0"/>
-              <a:buChar char="–"/>
-              <a:defRPr sz="1700" kern="1200">
-                <a:solidFill>
-                  <a:schemeClr val="tx1"/>
-                </a:solidFill>
-                <a:latin typeface="+mn-lt"/>
-                <a:ea typeface="+mn-ea"/>
-                <a:cs typeface="+mn-cs"/>
-              </a:defRPr>
-            </a:lvl6pPr>
-            <a:lvl7pPr marL="1280160" indent="-182880" algn="l" defTabSz="914400" rtl="0" eaLnBrk="1" latinLnBrk="0" hangingPunct="1">
-              <a:lnSpc>
-                <a:spcPct val="95000"/>
-              </a:lnSpc>
-              <a:spcBef>
-                <a:spcPts val="500"/>
-              </a:spcBef>
-              <a:buFont typeface="Arial" panose="020B0604020202020204" pitchFamily="34" charset="0"/>
-              <a:buChar char="–"/>
-              <a:defRPr sz="1700" kern="1200">
-                <a:solidFill>
-                  <a:schemeClr val="tx1"/>
-                </a:solidFill>
-                <a:latin typeface="+mn-lt"/>
-                <a:ea typeface="+mn-ea"/>
-                <a:cs typeface="+mn-cs"/>
-              </a:defRPr>
-            </a:lvl7pPr>
-            <a:lvl8pPr marL="1463040" indent="-182880" algn="l" defTabSz="914400" rtl="0" eaLnBrk="1" latinLnBrk="0" hangingPunct="1">
-              <a:lnSpc>
-                <a:spcPct val="95000"/>
-              </a:lnSpc>
-              <a:spcBef>
-                <a:spcPts val="500"/>
-              </a:spcBef>
-              <a:buFont typeface="Arial" panose="020B0604020202020204" pitchFamily="34" charset="0"/>
-              <a:buChar char="–"/>
-              <a:defRPr sz="1700" kern="1200">
-                <a:solidFill>
-                  <a:schemeClr val="tx1"/>
-                </a:solidFill>
-                <a:latin typeface="+mn-lt"/>
-                <a:ea typeface="+mn-ea"/>
-                <a:cs typeface="+mn-cs"/>
-              </a:defRPr>
-            </a:lvl8pPr>
-            <a:lvl9pPr marL="1645920" indent="-182880" algn="l" defTabSz="914400" rtl="0" eaLnBrk="1" latinLnBrk="0" hangingPunct="1">
-              <a:lnSpc>
-                <a:spcPct val="95000"/>
-              </a:lnSpc>
-              <a:spcBef>
-                <a:spcPts val="500"/>
-              </a:spcBef>
-              <a:buFont typeface="Arial" panose="020B0604020202020204" pitchFamily="34" charset="0"/>
-              <a:buChar char="–"/>
-              <a:defRPr sz="1700" kern="1200">
-                <a:solidFill>
-                  <a:schemeClr val="tx1"/>
-                </a:solidFill>
-                <a:latin typeface="+mn-lt"/>
-                <a:ea typeface="+mn-ea"/>
-                <a:cs typeface="+mn-cs"/>
-              </a:defRPr>
-            </a:lvl9pPr>
-          </a:lstStyle>
-          <a:p>
-            <a:r>
-              <a:rPr lang="en-US" sz="2800" dirty="0">
-                <a:solidFill>
-                  <a:schemeClr val="bg1"/>
-                </a:solidFill>
-              </a:rPr>
-              <a:t>Intelligence analysts have intercepted a transmission from an enemy outpost. The signal contains </a:t>
-            </a:r>
-            <a:r>
-              <a:rPr lang="en-US" sz="2800" b="1" dirty="0">
-                <a:solidFill>
-                  <a:schemeClr val="bg1"/>
-                </a:solidFill>
-              </a:rPr>
-              <a:t>100 scrambled numeric values</a:t>
-            </a:r>
-            <a:r>
-              <a:rPr lang="en-US" sz="2800" dirty="0">
-                <a:solidFill>
-                  <a:schemeClr val="bg1"/>
-                </a:solidFill>
-              </a:rPr>
-              <a:t> — but buried inside are the </a:t>
-            </a:r>
-            <a:r>
-              <a:rPr lang="en-US" sz="2800" b="1" dirty="0">
-                <a:solidFill>
-                  <a:schemeClr val="bg1"/>
-                </a:solidFill>
-              </a:rPr>
-              <a:t>true coordinates</a:t>
-            </a:r>
-            <a:r>
-              <a:rPr lang="en-US" sz="2800" dirty="0">
-                <a:solidFill>
-                  <a:schemeClr val="bg1"/>
-                </a:solidFill>
-              </a:rPr>
-              <a:t> of the enemy's hidden command center.</a:t>
-            </a:r>
-          </a:p>
-          <a:p>
-            <a:r>
-              <a:rPr lang="en-US" sz="2800" dirty="0">
-                <a:solidFill>
-                  <a:schemeClr val="bg1"/>
-                </a:solidFill>
-              </a:rPr>
-              <a:t>Your commanding officer explains: </a:t>
-            </a:r>
-            <a:r>
-              <a:rPr lang="en-US" sz="2800" i="1" dirty="0">
-                <a:solidFill>
-                  <a:schemeClr val="bg1"/>
-                </a:solidFill>
-              </a:rPr>
-              <a:t>"The enemy encodes their location by hiding it in plain sight. Take the </a:t>
-            </a:r>
-            <a:r>
-              <a:rPr lang="en-US" sz="2800" b="1" i="1" dirty="0">
-                <a:solidFill>
-                  <a:schemeClr val="bg1"/>
-                </a:solidFill>
-              </a:rPr>
-              <a:t>5 highest signal values</a:t>
-            </a:r>
-            <a:r>
-              <a:rPr lang="en-US" sz="2800" i="1" dirty="0">
-                <a:solidFill>
-                  <a:schemeClr val="bg1"/>
-                </a:solidFill>
-              </a:rPr>
-              <a:t>, sum them together, then divide by </a:t>
-            </a:r>
-            <a:r>
-              <a:rPr lang="en-US" sz="2800" b="1" i="1" dirty="0">
-                <a:solidFill>
-                  <a:schemeClr val="bg1"/>
-                </a:solidFill>
-              </a:rPr>
-              <a:t>10</a:t>
-            </a:r>
-            <a:r>
-              <a:rPr lang="en-US" sz="2800" i="1" dirty="0">
-                <a:solidFill>
-                  <a:schemeClr val="bg1"/>
-                </a:solidFill>
-              </a:rPr>
-              <a:t>. The result is the target's grid coordinate."</a:t>
-            </a:r>
-            <a:endParaRPr lang="en-US" sz="2800" dirty="0">
-              <a:solidFill>
-                <a:schemeClr val="bg1"/>
-              </a:solidFill>
-            </a:endParaRPr>
-          </a:p>
-          <a:p>
-            <a:r>
-              <a:rPr lang="en-US" sz="2800" dirty="0">
-                <a:solidFill>
-                  <a:schemeClr val="bg1"/>
-                </a:solidFill>
-              </a:rPr>
+          <a:lstStyle/>
+          <a:p>
+            <a:r>
+              <a:rPr lang="en-US" sz="2400" dirty="0"/>
+              <a:t>Intelligence analysts have intercepted a transmission from an enemy outpost. The signal contains 100 scrambled numeric values — but buried inside are the true coordinates of the enemy's hidden command center.</a:t>
+            </a:r>
+          </a:p>
+          <a:p>
+            <a:r>
+              <a:rPr lang="en-US" sz="2400" dirty="0"/>
+              <a:t>Your commanding officer explains: "The enemy encodes their location by hiding it in plain sight. Take the 5 highest signal values, sum them together, then divide by 10. The result is the target's grid coordinate."</a:t>
+            </a:r>
+          </a:p>
+          <a:p>
+            <a:r>
+              <a:rPr lang="en-US" sz="2400" dirty="0"/>
               <a:t>Your mission: write a Python program to decode the transmission and report the coordinates.  You have 20 minutes to finish this before the enemy moves their command post.</a:t>
             </a:r>
           </a:p>
@@ -39700,59 +39726,39 @@
             <a:spLocks noGrp="1"/>
           </p:cNvSpPr>
           <p:nvPr>
-            <p:ph type="body" sz="quarter" idx="11"/>
+            <p:ph idx="1"/>
           </p:nvPr>
         </p:nvSpPr>
         <p:spPr>
           <a:xfrm>
-            <a:off x="548640" y="2148840"/>
-            <a:ext cx="10601960" cy="4023360"/>
+            <a:off x="548639" y="1600198"/>
+            <a:ext cx="8875915" cy="4572000"/>
           </a:xfrm>
         </p:spPr>
         <p:txBody>
           <a:bodyPr/>
           <a:lstStyle/>
           <a:p>
-            <a:pPr marL="457200" indent="-457200">
-              <a:buFont typeface="Arial" panose="020B0604020202020204" pitchFamily="34" charset="0"/>
-              <a:buChar char="•"/>
-            </a:pPr>
-            <a:r>
-              <a:rPr lang="en-US" dirty="0"/>
+            <a:r>
+              <a:rPr lang="en-US" sz="2000" dirty="0"/>
               <a:t>Understand the difference between lists, tuples, dictionaries, and sets.</a:t>
             </a:r>
           </a:p>
           <a:p>
-            <a:pPr marL="457200" indent="-457200">
-              <a:buFont typeface="Arial" panose="020B0604020202020204" pitchFamily="34" charset="0"/>
-              <a:buChar char="•"/>
-            </a:pPr>
-            <a:endParaRPr lang="en-US" dirty="0"/>
-          </a:p>
-          <a:p>
-            <a:pPr marL="457200" indent="-457200">
-              <a:buFont typeface="Arial" panose="020B0604020202020204" pitchFamily="34" charset="0"/>
-              <a:buChar char="•"/>
-            </a:pPr>
-            <a:r>
-              <a:rPr lang="en-US" dirty="0"/>
+            <a:endParaRPr lang="en-US" sz="2000" dirty="0"/>
+          </a:p>
+          <a:p>
+            <a:r>
+              <a:rPr lang="en-US" sz="2000" dirty="0"/>
               <a:t>Know when and how to apply nested lists</a:t>
             </a:r>
           </a:p>
           <a:p>
-            <a:pPr marL="457200" indent="-457200">
-              <a:buFont typeface="Arial" panose="020B0604020202020204" pitchFamily="34" charset="0"/>
-              <a:buChar char="•"/>
-            </a:pPr>
-            <a:endParaRPr lang="en-US" dirty="0"/>
-          </a:p>
-          <a:p>
-            <a:pPr marL="457200" indent="-457200">
-              <a:buFont typeface="Arial" panose="020B0604020202020204" pitchFamily="34" charset="0"/>
-              <a:buChar char="•"/>
-            </a:pPr>
-            <a:r>
-              <a:rPr lang="en-US" dirty="0"/>
+            <a:endParaRPr lang="en-US" sz="2000" dirty="0"/>
+          </a:p>
+          <a:p>
+            <a:r>
+              <a:rPr lang="en-US" sz="2000" dirty="0"/>
               <a:t>Implement and discuss some basic list manipulation techniques</a:t>
             </a:r>
           </a:p>
@@ -39804,12 +39810,7 @@
             <p:ph type="title"/>
           </p:nvPr>
         </p:nvSpPr>
-        <p:spPr>
-          <a:xfrm>
-            <a:off x="549275" y="388461"/>
-            <a:ext cx="8231293" cy="1189037"/>
-          </a:xfrm>
-        </p:spPr>
+        <p:spPr/>
         <p:txBody>
           <a:bodyPr/>
           <a:lstStyle/>
@@ -41189,8 +41190,8 @@
         </p:nvSpPr>
         <p:spPr>
           <a:xfrm>
-            <a:off x="873493" y="1277675"/>
-            <a:ext cx="6097604" cy="1477328"/>
+            <a:off x="873492" y="1277675"/>
+            <a:ext cx="10769867" cy="1477328"/>
           </a:xfrm>
           <a:prstGeom prst="rect">
             <a:avLst/>
@@ -41204,35 +41205,56 @@
           <a:lstStyle/>
           <a:p>
             <a:r>
-              <a:rPr lang="en-US" dirty="0"/>
+              <a:rPr lang="en-US" dirty="0">
+                <a:latin typeface="Courier New" panose="02070309020205020404" pitchFamily="49" charset="0"/>
+                <a:cs typeface="Courier New" panose="02070309020205020404" pitchFamily="49" charset="0"/>
+              </a:rPr>
               <a:t># Empty list</a:t>
             </a:r>
           </a:p>
           <a:p>
             <a:r>
-              <a:rPr lang="en-US" dirty="0" err="1"/>
+              <a:rPr lang="en-US" dirty="0" err="1">
+                <a:latin typeface="Courier New" panose="02070309020205020404" pitchFamily="49" charset="0"/>
+                <a:cs typeface="Courier New" panose="02070309020205020404" pitchFamily="49" charset="0"/>
+              </a:rPr>
               <a:t>my_list</a:t>
             </a:r>
             <a:r>
-              <a:rPr lang="en-US" dirty="0"/>
+              <a:rPr lang="en-US" dirty="0">
+                <a:latin typeface="Courier New" panose="02070309020205020404" pitchFamily="49" charset="0"/>
+                <a:cs typeface="Courier New" panose="02070309020205020404" pitchFamily="49" charset="0"/>
+              </a:rPr>
               <a:t> = []</a:t>
             </a:r>
           </a:p>
           <a:p>
             <a:r>
-              <a:rPr lang="en-US" dirty="0" err="1"/>
+              <a:rPr lang="en-US" dirty="0" err="1">
+                <a:latin typeface="Courier New" panose="02070309020205020404" pitchFamily="49" charset="0"/>
+                <a:cs typeface="Courier New" panose="02070309020205020404" pitchFamily="49" charset="0"/>
+              </a:rPr>
               <a:t>my_list</a:t>
             </a:r>
             <a:r>
-              <a:rPr lang="en-US" dirty="0"/>
+              <a:rPr lang="en-US" dirty="0">
+                <a:latin typeface="Courier New" panose="02070309020205020404" pitchFamily="49" charset="0"/>
+                <a:cs typeface="Courier New" panose="02070309020205020404" pitchFamily="49" charset="0"/>
+              </a:rPr>
               <a:t> = list()</a:t>
             </a:r>
           </a:p>
           <a:p>
-            <a:endParaRPr lang="en-US" dirty="0"/>
-          </a:p>
-          <a:p>
-            <a:endParaRPr lang="en-US" dirty="0"/>
+            <a:endParaRPr lang="en-US" dirty="0">
+              <a:latin typeface="Courier New" panose="02070309020205020404" pitchFamily="49" charset="0"/>
+              <a:cs typeface="Courier New" panose="02070309020205020404" pitchFamily="49" charset="0"/>
+            </a:endParaRPr>
+          </a:p>
+          <a:p>
+            <a:endParaRPr lang="en-US" dirty="0">
+              <a:latin typeface="Courier New" panose="02070309020205020404" pitchFamily="49" charset="0"/>
+              <a:cs typeface="Courier New" panose="02070309020205020404" pitchFamily="49" charset="0"/>
+            </a:endParaRPr>
           </a:p>
         </p:txBody>
       </p:sp>
@@ -41250,8 +41272,8 @@
         </p:nvSpPr>
         <p:spPr>
           <a:xfrm>
-            <a:off x="873493" y="2380192"/>
-            <a:ext cx="6097604" cy="1200329"/>
+            <a:off x="873492" y="2380192"/>
+            <a:ext cx="10769867" cy="1200329"/>
           </a:xfrm>
           <a:prstGeom prst="rect">
             <a:avLst/>
@@ -41265,25 +41287,40 @@
           <a:lstStyle/>
           <a:p>
             <a:r>
-              <a:rPr lang="en-US" dirty="0"/>
+              <a:rPr lang="en-US" dirty="0">
+                <a:latin typeface="Courier New" panose="02070309020205020404" pitchFamily="49" charset="0"/>
+                <a:cs typeface="Courier New" panose="02070309020205020404" pitchFamily="49" charset="0"/>
+              </a:rPr>
               <a:t># With values</a:t>
             </a:r>
           </a:p>
           <a:p>
             <a:r>
-              <a:rPr lang="en-US" dirty="0" err="1"/>
+              <a:rPr lang="en-US" dirty="0" err="1">
+                <a:latin typeface="Courier New" panose="02070309020205020404" pitchFamily="49" charset="0"/>
+                <a:cs typeface="Courier New" panose="02070309020205020404" pitchFamily="49" charset="0"/>
+              </a:rPr>
               <a:t>my_list</a:t>
             </a:r>
             <a:r>
-              <a:rPr lang="en-US" dirty="0"/>
+              <a:rPr lang="en-US" dirty="0">
+                <a:latin typeface="Courier New" panose="02070309020205020404" pitchFamily="49" charset="0"/>
+                <a:cs typeface="Courier New" panose="02070309020205020404" pitchFamily="49" charset="0"/>
+              </a:rPr>
               <a:t> = [1, 2, 3]</a:t>
             </a:r>
           </a:p>
           <a:p>
-            <a:endParaRPr lang="en-US" dirty="0"/>
-          </a:p>
-          <a:p>
-            <a:endParaRPr lang="en-US" dirty="0"/>
+            <a:endParaRPr lang="en-US" dirty="0">
+              <a:latin typeface="Courier New" panose="02070309020205020404" pitchFamily="49" charset="0"/>
+              <a:cs typeface="Courier New" panose="02070309020205020404" pitchFamily="49" charset="0"/>
+            </a:endParaRPr>
+          </a:p>
+          <a:p>
+            <a:endParaRPr lang="en-US" dirty="0">
+              <a:latin typeface="Courier New" panose="02070309020205020404" pitchFamily="49" charset="0"/>
+              <a:cs typeface="Courier New" panose="02070309020205020404" pitchFamily="49" charset="0"/>
+            </a:endParaRPr>
           </a:p>
         </p:txBody>
       </p:sp>
@@ -41301,8 +41338,8 @@
         </p:nvSpPr>
         <p:spPr>
           <a:xfrm>
-            <a:off x="873493" y="3364334"/>
-            <a:ext cx="6097604" cy="1477328"/>
+            <a:off x="873492" y="3364334"/>
+            <a:ext cx="10769867" cy="1477328"/>
           </a:xfrm>
           <a:prstGeom prst="rect">
             <a:avLst/>
@@ -41316,47 +41353,77 @@
           <a:lstStyle/>
           <a:p>
             <a:r>
-              <a:rPr lang="en-US" dirty="0"/>
+              <a:rPr lang="en-US" dirty="0">
+                <a:latin typeface="Courier New" panose="02070309020205020404" pitchFamily="49" charset="0"/>
+                <a:cs typeface="Courier New" panose="02070309020205020404" pitchFamily="49" charset="0"/>
+              </a:rPr>
               <a:t># From another </a:t>
             </a:r>
             <a:r>
-              <a:rPr lang="en-US" dirty="0" err="1"/>
+              <a:rPr lang="en-US" dirty="0" err="1">
+                <a:latin typeface="Courier New" panose="02070309020205020404" pitchFamily="49" charset="0"/>
+                <a:cs typeface="Courier New" panose="02070309020205020404" pitchFamily="49" charset="0"/>
+              </a:rPr>
               <a:t>iterable</a:t>
             </a:r>
-            <a:endParaRPr lang="en-US" dirty="0"/>
-          </a:p>
-          <a:p>
-            <a:r>
-              <a:rPr lang="en-US" dirty="0" err="1"/>
+            <a:endParaRPr lang="en-US" dirty="0">
+              <a:latin typeface="Courier New" panose="02070309020205020404" pitchFamily="49" charset="0"/>
+              <a:cs typeface="Courier New" panose="02070309020205020404" pitchFamily="49" charset="0"/>
+            </a:endParaRPr>
+          </a:p>
+          <a:p>
+            <a:r>
+              <a:rPr lang="en-US" dirty="0" err="1">
+                <a:latin typeface="Courier New" panose="02070309020205020404" pitchFamily="49" charset="0"/>
+                <a:cs typeface="Courier New" panose="02070309020205020404" pitchFamily="49" charset="0"/>
+              </a:rPr>
               <a:t>my_list</a:t>
             </a:r>
             <a:r>
-              <a:rPr lang="en-US" dirty="0"/>
+              <a:rPr lang="en-US" dirty="0">
+                <a:latin typeface="Courier New" panose="02070309020205020404" pitchFamily="49" charset="0"/>
+                <a:cs typeface="Courier New" panose="02070309020205020404" pitchFamily="49" charset="0"/>
+              </a:rPr>
               <a:t> = list("hello")        # ['h', 'e', 'l', 'l', 'o']</a:t>
             </a:r>
           </a:p>
           <a:p>
             <a:r>
-              <a:rPr lang="en-US" dirty="0" err="1"/>
+              <a:rPr lang="en-US" dirty="0" err="1">
+                <a:latin typeface="Courier New" panose="02070309020205020404" pitchFamily="49" charset="0"/>
+                <a:cs typeface="Courier New" panose="02070309020205020404" pitchFamily="49" charset="0"/>
+              </a:rPr>
               <a:t>my_list</a:t>
             </a:r>
             <a:r>
-              <a:rPr lang="en-US" dirty="0"/>
+              <a:rPr lang="en-US" dirty="0">
+                <a:latin typeface="Courier New" panose="02070309020205020404" pitchFamily="49" charset="0"/>
+                <a:cs typeface="Courier New" panose="02070309020205020404" pitchFamily="49" charset="0"/>
+              </a:rPr>
               <a:t> = list((1, 2, 3))      # [1, 2, 3]  (from a tuple)</a:t>
             </a:r>
           </a:p>
           <a:p>
             <a:r>
-              <a:rPr lang="en-US" dirty="0" err="1"/>
+              <a:rPr lang="en-US" dirty="0" err="1">
+                <a:latin typeface="Courier New" panose="02070309020205020404" pitchFamily="49" charset="0"/>
+                <a:cs typeface="Courier New" panose="02070309020205020404" pitchFamily="49" charset="0"/>
+              </a:rPr>
               <a:t>my_list</a:t>
             </a:r>
             <a:r>
-              <a:rPr lang="en-US" dirty="0"/>
+              <a:rPr lang="en-US" dirty="0">
+                <a:latin typeface="Courier New" panose="02070309020205020404" pitchFamily="49" charset="0"/>
+                <a:cs typeface="Courier New" panose="02070309020205020404" pitchFamily="49" charset="0"/>
+              </a:rPr>
               <a:t> = list(range(5))       # [0, 1, 2, 3, 4]</a:t>
             </a:r>
           </a:p>
           <a:p>
-            <a:endParaRPr lang="en-US" dirty="0"/>
+            <a:endParaRPr lang="en-US" dirty="0">
+              <a:latin typeface="Courier New" panose="02070309020205020404" pitchFamily="49" charset="0"/>
+              <a:cs typeface="Courier New" panose="02070309020205020404" pitchFamily="49" charset="0"/>
+            </a:endParaRPr>
           </a:p>
         </p:txBody>
       </p:sp>
@@ -41374,8 +41441,8 @@
         </p:nvSpPr>
         <p:spPr>
           <a:xfrm>
-            <a:off x="873493" y="4760040"/>
-            <a:ext cx="6097604" cy="923330"/>
+            <a:off x="873492" y="4760040"/>
+            <a:ext cx="10769867" cy="923330"/>
           </a:xfrm>
           <a:prstGeom prst="rect">
             <a:avLst/>
@@ -41389,22 +41456,34 @@
           <a:lstStyle/>
           <a:p>
             <a:r>
-              <a:rPr lang="en-US" dirty="0"/>
+              <a:rPr lang="en-US" dirty="0">
+                <a:latin typeface="Courier New" panose="02070309020205020404" pitchFamily="49" charset="0"/>
+                <a:cs typeface="Courier New" panose="02070309020205020404" pitchFamily="49" charset="0"/>
+              </a:rPr>
               <a:t># List comprehension</a:t>
             </a:r>
           </a:p>
           <a:p>
             <a:r>
-              <a:rPr lang="en-US" dirty="0" err="1"/>
+              <a:rPr lang="en-US" dirty="0" err="1">
+                <a:latin typeface="Courier New" panose="02070309020205020404" pitchFamily="49" charset="0"/>
+                <a:cs typeface="Courier New" panose="02070309020205020404" pitchFamily="49" charset="0"/>
+              </a:rPr>
               <a:t>my_list</a:t>
             </a:r>
             <a:r>
-              <a:rPr lang="en-US" dirty="0"/>
+              <a:rPr lang="en-US" dirty="0">
+                <a:latin typeface="Courier New" panose="02070309020205020404" pitchFamily="49" charset="0"/>
+                <a:cs typeface="Courier New" panose="02070309020205020404" pitchFamily="49" charset="0"/>
+              </a:rPr>
               <a:t> = [x * 2 for x in range(5)]   # [0, 2, 4, 6, 8]</a:t>
             </a:r>
           </a:p>
           <a:p>
-            <a:endParaRPr lang="en-US" dirty="0"/>
+            <a:endParaRPr lang="en-US" dirty="0">
+              <a:latin typeface="Courier New" panose="02070309020205020404" pitchFamily="49" charset="0"/>
+              <a:cs typeface="Courier New" panose="02070309020205020404" pitchFamily="49" charset="0"/>
+            </a:endParaRPr>
           </a:p>
         </p:txBody>
       </p:sp>
@@ -41422,8 +41501,8 @@
         </p:nvSpPr>
         <p:spPr>
           <a:xfrm>
-            <a:off x="873493" y="5683370"/>
-            <a:ext cx="6097604" cy="646331"/>
+            <a:off x="873492" y="5683370"/>
+            <a:ext cx="10769867" cy="646331"/>
           </a:xfrm>
           <a:prstGeom prst="rect">
             <a:avLst/>
@@ -41437,17 +41516,26 @@
           <a:lstStyle/>
           <a:p>
             <a:r>
-              <a:rPr lang="en-US" dirty="0"/>
+              <a:rPr lang="en-US" dirty="0">
+                <a:latin typeface="Courier New" panose="02070309020205020404" pitchFamily="49" charset="0"/>
+                <a:cs typeface="Courier New" panose="02070309020205020404" pitchFamily="49" charset="0"/>
+              </a:rPr>
               <a:t># Repeated values</a:t>
             </a:r>
           </a:p>
           <a:p>
             <a:r>
-              <a:rPr lang="en-US" dirty="0" err="1"/>
+              <a:rPr lang="en-US" dirty="0" err="1">
+                <a:latin typeface="Courier New" panose="02070309020205020404" pitchFamily="49" charset="0"/>
+                <a:cs typeface="Courier New" panose="02070309020205020404" pitchFamily="49" charset="0"/>
+              </a:rPr>
               <a:t>my_list</a:t>
             </a:r>
             <a:r>
-              <a:rPr lang="en-US" dirty="0"/>
+              <a:rPr lang="en-US" dirty="0">
+                <a:latin typeface="Courier New" panose="02070309020205020404" pitchFamily="49" charset="0"/>
+                <a:cs typeface="Courier New" panose="02070309020205020404" pitchFamily="49" charset="0"/>
+              </a:rPr>
               <a:t> = [0] * 5              # [0, 0, 0, 0, 0]</a:t>
             </a:r>
           </a:p>
@@ -41729,7 +41817,7 @@
 </file>
 
 <file path=ppt/slides/slide9.xml><?xml version="1.0" encoding="utf-8"?>
-<p:sld xmlns:a="http://schemas.openxmlformats.org/drawingml/2006/main" xmlns:r="http://schemas.openxmlformats.org/officeDocument/2006/relationships" xmlns:p="http://schemas.openxmlformats.org/presentationml/2006/main">
+<p:sld xmlns:a="http://schemas.openxmlformats.org/drawingml/2006/main" xmlns:r="http://schemas.openxmlformats.org/officeDocument/2006/relationships" xmlns:p="http://schemas.openxmlformats.org/presentationml/2006/main" show="0">
   <p:cSld>
     <p:spTree>
       <p:nvGrpSpPr>
@@ -41751,44 +41839,6 @@
           <a:chExt cx="0" cy="0"/>
         </a:xfrm>
       </p:grpSpPr>
-      <p:sp>
-        <p:nvSpPr>
-          <p:cNvPr id="5" name="Title 4">
-            <a:extLst>
-              <a:ext uri="{FF2B5EF4-FFF2-40B4-BE49-F238E27FC236}">
-                <a16:creationId xmlns:a16="http://schemas.microsoft.com/office/drawing/2014/main" id="{A70E1794-6332-AE7C-0CCE-1ACC181C2B2B}"/>
-              </a:ext>
-            </a:extLst>
-          </p:cNvPr>
-          <p:cNvSpPr>
-            <a:spLocks noGrp="1"/>
-          </p:cNvSpPr>
-          <p:nvPr>
-            <p:ph type="title"/>
-          </p:nvPr>
-        </p:nvSpPr>
-        <p:spPr>
-          <a:xfrm>
-            <a:off x="549275" y="388461"/>
-            <a:ext cx="8231293" cy="1189037"/>
-          </a:xfrm>
-        </p:spPr>
-        <p:txBody>
-          <a:bodyPr/>
-          <a:lstStyle/>
-          <a:p>
-            <a:r>
-              <a:rPr lang="en-US" dirty="0"/>
-              <a:t>List Methods </a:t>
-            </a:r>
-            <a:r>
-              <a:rPr lang="en-US" dirty="0" err="1"/>
-              <a:t>Cheatsheet</a:t>
-            </a:r>
-            <a:endParaRPr lang="en-US" dirty="0"/>
-          </a:p>
-        </p:txBody>
-      </p:sp>
       <p:graphicFrame>
         <p:nvGraphicFramePr>
           <p:cNvPr id="2" name="Table 1">
@@ -44899,6 +44949,39 @@
           </a:graphicData>
         </a:graphic>
       </p:graphicFrame>
+      <p:sp>
+        <p:nvSpPr>
+          <p:cNvPr id="5" name="Title 4">
+            <a:extLst>
+              <a:ext uri="{FF2B5EF4-FFF2-40B4-BE49-F238E27FC236}">
+                <a16:creationId xmlns:a16="http://schemas.microsoft.com/office/drawing/2014/main" id="{A70E1794-6332-AE7C-0CCE-1ACC181C2B2B}"/>
+              </a:ext>
+            </a:extLst>
+          </p:cNvPr>
+          <p:cNvSpPr>
+            <a:spLocks noGrp="1"/>
+          </p:cNvSpPr>
+          <p:nvPr>
+            <p:ph type="title"/>
+          </p:nvPr>
+        </p:nvSpPr>
+        <p:spPr/>
+        <p:txBody>
+          <a:bodyPr/>
+          <a:lstStyle/>
+          <a:p>
+            <a:r>
+              <a:rPr lang="en-US" dirty="0"/>
+              <a:t>List Methods </a:t>
+            </a:r>
+            <a:r>
+              <a:rPr lang="en-US" dirty="0" err="1"/>
+              <a:t>Cheatsheet</a:t>
+            </a:r>
+            <a:endParaRPr lang="en-US" dirty="0"/>
+          </a:p>
+        </p:txBody>
+      </p:sp>
     </p:spTree>
     <p:extLst>
       <p:ext uri="{BB962C8B-B14F-4D97-AF65-F5344CB8AC3E}">

</xml_diff>